<commit_message>
Tested api and integration
</commit_message>
<xml_diff>
--- a/PawVibe_Hackathon_Pitch_Deck.pptx
+++ b/PawVibe_Hackathon_Pitch_Deck.pptx
@@ -4,17 +4,20 @@
   <p:sldMasterIdLst>
     <p:sldMasterId id="2147483648" r:id="rId1"/>
   </p:sldMasterIdLst>
+  <p:notesMasterIdLst>
+    <p:notesMasterId r:id="rId10"/>
+  </p:notesMasterIdLst>
   <p:sldIdLst>
-    <p:sldId id="256" r:id="rId7"/>
-    <p:sldId id="257" r:id="rId9"/>
-    <p:sldId id="258" r:id="rId10"/>
-    <p:sldId id="259" r:id="rId11"/>
-    <p:sldId id="260" r:id="rId12"/>
-    <p:sldId id="261" r:id="rId13"/>
-    <p:sldId id="262" r:id="rId14"/>
-    <p:sldId id="263" r:id="rId15"/>
+    <p:sldId id="256" r:id="rId2"/>
+    <p:sldId id="257" r:id="rId3"/>
+    <p:sldId id="258" r:id="rId4"/>
+    <p:sldId id="259" r:id="rId5"/>
+    <p:sldId id="260" r:id="rId6"/>
+    <p:sldId id="261" r:id="rId7"/>
+    <p:sldId id="262" r:id="rId8"/>
+    <p:sldId id="263" r:id="rId9"/>
   </p:sldIdLst>
-  <p:sldSz cx="12191695" cy="6858000" type="screen4x3"/>
+  <p:sldSz cx="12192000" cy="6858000"/>
   <p:notesSz cx="6858000" cy="9144000"/>
   <p:defaultTextStyle>
     <a:defPPr>
@@ -111,11 +114,27 @@
       </a:defRPr>
     </a:lvl9pPr>
   </p:defaultTextStyle>
+  <p:extLst>
+    <p:ext uri="{EFAFB233-063F-42B5-8137-9DF3F51BA10A}">
+      <p15:sldGuideLst xmlns:p15="http://schemas.microsoft.com/office/powerpoint/2012/main">
+        <p15:guide id="1" orient="horz" pos="2160">
+          <p15:clr>
+            <a:srgbClr val="A4A3A4"/>
+          </p15:clr>
+        </p15:guide>
+        <p15:guide id="2" pos="2880">
+          <p15:clr>
+            <a:srgbClr val="A4A3A4"/>
+          </p15:clr>
+        </p15:guide>
+      </p15:sldGuideLst>
+    </p:ext>
+  </p:extLst>
 </p:presentation>
 </file>
 
 <file path=ppt/notesMasters/notesMaster1.xml><?xml version="1.0" encoding="utf-8"?>
-<p:notesMaster xmlns:a="http://schemas.openxmlformats.org/drawingml/2006/main" xmlns:p="http://schemas.openxmlformats.org/presentationml/2006/main" xmlns:r="http://schemas.openxmlformats.org/officeDocument/2006/relationships">
+<p:notesMaster xmlns:a="http://schemas.openxmlformats.org/drawingml/2006/main" xmlns:r="http://schemas.openxmlformats.org/officeDocument/2006/relationships" xmlns:p="http://schemas.openxmlformats.org/presentationml/2006/main">
   <p:cSld>
     <p:bg>
       <p:bgRef idx="1001">
@@ -136,241 +155,16 @@
           <a:chExt cx="0" cy="0"/>
         </a:xfrm>
       </p:grpSpPr>
-      <p:sp>
-        <p:nvSpPr>
-          <p:cNvPr id="2" name="Header Placeholder 1"/>
-          <p:cNvSpPr>
-            <a:spLocks noGrp="1"/>
-          </p:cNvSpPr>
-          <p:nvPr>
-            <p:ph type="hdr" sz="quarter"/>
-          </p:nvPr>
-        </p:nvSpPr>
-        <p:spPr>
-          <a:xfrm>
-            <a:off x="0" y="0"/>
-            <a:ext cx="2971800" cy="457200"/>
-          </a:xfrm>
-          <a:prstGeom prst="rect">
-            <a:avLst/>
-          </a:prstGeom>
-        </p:spPr>
-        <p:txBody>
-          <a:bodyPr vert="horz" lIns="91440" tIns="45720" rIns="91440" bIns="45720" rtlCol="0"/>
-          <a:lstStyle>
-            <a:lvl1pPr algn="l">
-              <a:defRPr sz="1200"/>
-            </a:lvl1pPr>
-          </a:lstStyle>
-          <a:p>
-            <a:endParaRPr lang="en-US"/>
-          </a:p>
-        </p:txBody>
-      </p:sp>
-      <p:sp>
-        <p:nvSpPr>
-          <p:cNvPr id="3" name="Date Placeholder 2"/>
-          <p:cNvSpPr>
-            <a:spLocks noGrp="1"/>
-          </p:cNvSpPr>
-          <p:nvPr>
-            <p:ph type="dt" idx="1"/>
-          </p:nvPr>
-        </p:nvSpPr>
-        <p:spPr>
-          <a:xfrm>
-            <a:off x="3884613" y="0"/>
-            <a:ext cx="2971800" cy="457200"/>
-          </a:xfrm>
-          <a:prstGeom prst="rect">
-            <a:avLst/>
-          </a:prstGeom>
-        </p:spPr>
-        <p:txBody>
-          <a:bodyPr vert="horz" lIns="91440" tIns="45720" rIns="91440" bIns="45720" rtlCol="0"/>
-          <a:lstStyle>
-            <a:lvl1pPr algn="r">
-              <a:defRPr sz="1200"/>
-            </a:lvl1pPr>
-          </a:lstStyle>
-          <a:p>
-            <a:fld id="{0F89C1C7-3DCD-1040-A9CF-14679D8B5DDD}" type="datetimeFigureOut">
-              <a:rPr lang="en-US" smtClean="0"/>
-              <a:t>10/17/16</a:t>
-            </a:fld>
-            <a:endParaRPr lang="en-US"/>
-          </a:p>
-        </p:txBody>
-      </p:sp>
-      <p:sp>
-        <p:nvSpPr>
-          <p:cNvPr id="4" name="Slide Image Placeholder 3"/>
-          <p:cNvSpPr>
-            <a:spLocks noGrp="1" noRot="1" noChangeAspect="1"/>
-          </p:cNvSpPr>
-          <p:nvPr>
-            <p:ph type="sldImg" idx="2"/>
-          </p:nvPr>
-        </p:nvSpPr>
-        <p:spPr>
-          <a:xfrm>
-            <a:off x="1143000" y="685800"/>
-            <a:ext cx="4572000" cy="3429000"/>
-          </a:xfrm>
-          <a:prstGeom prst="rect">
-            <a:avLst/>
-          </a:prstGeom>
-          <a:noFill/>
-          <a:ln w="12700">
-            <a:solidFill>
-              <a:prstClr val="black"/>
-            </a:solidFill>
-          </a:ln>
-        </p:spPr>
-        <p:txBody>
-          <a:bodyPr vert="horz" lIns="91440" tIns="45720" rIns="91440" bIns="45720" rtlCol="0" anchor="ctr"/>
-          <a:lstStyle/>
-          <a:p>
-            <a:endParaRPr lang="en-US"/>
-          </a:p>
-        </p:txBody>
-      </p:sp>
-      <p:sp>
-        <p:nvSpPr>
-          <p:cNvPr id="5" name="Notes Placeholder 4"/>
-          <p:cNvSpPr>
-            <a:spLocks noGrp="1"/>
-          </p:cNvSpPr>
-          <p:nvPr>
-            <p:ph type="body" sz="quarter" idx="3"/>
-          </p:nvPr>
-        </p:nvSpPr>
-        <p:spPr>
-          <a:xfrm>
-            <a:off x="685800" y="4343400"/>
-            <a:ext cx="5486400" cy="4114800"/>
-          </a:xfrm>
-          <a:prstGeom prst="rect">
-            <a:avLst/>
-          </a:prstGeom>
-        </p:spPr>
-        <p:txBody>
-          <a:bodyPr vert="horz" lIns="91440" tIns="45720" rIns="91440" bIns="45720" rtlCol="0"/>
-          <a:lstStyle/>
-          <a:p>
-            <a:pPr lvl="0"/>
-            <a:r>
-              <a:rPr lang="en-US" smtClean="0"/>
-              <a:t>Click to edit Master text styles</a:t>
-            </a:r>
-          </a:p>
-          <a:p>
-            <a:pPr lvl="1"/>
-            <a:r>
-              <a:rPr lang="en-US" smtClean="0"/>
-              <a:t>Second level</a:t>
-            </a:r>
-          </a:p>
-          <a:p>
-            <a:pPr lvl="2"/>
-            <a:r>
-              <a:rPr lang="en-US" smtClean="0"/>
-              <a:t>Third level</a:t>
-            </a:r>
-          </a:p>
-          <a:p>
-            <a:pPr lvl="3"/>
-            <a:r>
-              <a:rPr lang="en-US" smtClean="0"/>
-              <a:t>Fourth level</a:t>
-            </a:r>
-          </a:p>
-          <a:p>
-            <a:pPr lvl="4"/>
-            <a:r>
-              <a:rPr lang="en-US" smtClean="0"/>
-              <a:t>Fifth level</a:t>
-            </a:r>
-            <a:endParaRPr lang="en-US"/>
-          </a:p>
-        </p:txBody>
-      </p:sp>
-      <p:sp>
-        <p:nvSpPr>
-          <p:cNvPr id="6" name="Footer Placeholder 5"/>
-          <p:cNvSpPr>
-            <a:spLocks noGrp="1"/>
-          </p:cNvSpPr>
-          <p:nvPr>
-            <p:ph type="ftr" sz="quarter" idx="4"/>
-          </p:nvPr>
-        </p:nvSpPr>
-        <p:spPr>
-          <a:xfrm>
-            <a:off x="0" y="8685213"/>
-            <a:ext cx="2971800" cy="457200"/>
-          </a:xfrm>
-          <a:prstGeom prst="rect">
-            <a:avLst/>
-          </a:prstGeom>
-        </p:spPr>
-        <p:txBody>
-          <a:bodyPr vert="horz" lIns="91440" tIns="45720" rIns="91440" bIns="45720" rtlCol="0" anchor="b"/>
-          <a:lstStyle>
-            <a:lvl1pPr algn="l">
-              <a:defRPr sz="1200"/>
-            </a:lvl1pPr>
-          </a:lstStyle>
-          <a:p>
-            <a:endParaRPr lang="en-US"/>
-          </a:p>
-        </p:txBody>
-      </p:sp>
-      <p:sp>
-        <p:nvSpPr>
-          <p:cNvPr id="7" name="Slide Number Placeholder 6"/>
-          <p:cNvSpPr>
-            <a:spLocks noGrp="1"/>
-          </p:cNvSpPr>
-          <p:nvPr>
-            <p:ph type="sldNum" sz="quarter" idx="5"/>
-          </p:nvPr>
-        </p:nvSpPr>
-        <p:spPr>
-          <a:xfrm>
-            <a:off x="3884613" y="8685213"/>
-            <a:ext cx="2971800" cy="457200"/>
-          </a:xfrm>
-          <a:prstGeom prst="rect">
-            <a:avLst/>
-          </a:prstGeom>
-        </p:spPr>
-        <p:txBody>
-          <a:bodyPr vert="horz" lIns="91440" tIns="45720" rIns="91440" bIns="45720" rtlCol="0" anchor="b"/>
-          <a:lstStyle>
-            <a:lvl1pPr algn="r">
-              <a:defRPr sz="1200"/>
-            </a:lvl1pPr>
-          </a:lstStyle>
-          <a:p>
-            <a:fld id="{BB5E49A5-4136-284D-997B-48E1D791AD67}" type="slidenum">
-              <a:rPr lang="en-US" smtClean="0"/>
-              <a:t>‹#›</a:t>
-            </a:fld>
-            <a:endParaRPr lang="en-US"/>
-          </a:p>
-        </p:txBody>
-      </p:sp>
     </p:spTree>
     <p:extLst>
       <p:ext uri="{BB962C8B-B14F-4D97-AF65-F5344CB8AC3E}">
-        <p14:creationId xmlns:p14="http://schemas.microsoft.com/office/powerpoint/2010/main" val="2623252185"/>
+        <p14:creationId xmlns:p14="http://schemas.microsoft.com/office/powerpoint/2010/main" val="2911254435"/>
       </p:ext>
     </p:extLst>
   </p:cSld>
   <p:clrMap bg1="lt1" tx1="dk1" bg2="lt2" tx2="dk2" accent1="accent1" accent2="accent2" accent3="accent3" accent4="accent4" accent5="accent5" accent6="accent6" hlink="hlink" folHlink="folHlink"/>
   <p:notesStyle>
-    <a:lvl1pPr marL="0" algn="l" defTabSz="457200" rtl="0" eaLnBrk="1" latinLnBrk="0" hangingPunct="1">
+    <a:lvl1pPr marL="0" algn="l" defTabSz="914400" rtl="0" eaLnBrk="1" latinLnBrk="0" hangingPunct="1">
       <a:defRPr sz="1200" kern="1200">
         <a:solidFill>
           <a:schemeClr val="tx1"/>
@@ -380,7 +174,7 @@
         <a:cs typeface="+mn-cs"/>
       </a:defRPr>
     </a:lvl1pPr>
-    <a:lvl2pPr marL="457200" algn="l" defTabSz="457200" rtl="0" eaLnBrk="1" latinLnBrk="0" hangingPunct="1">
+    <a:lvl2pPr marL="457200" algn="l" defTabSz="914400" rtl="0" eaLnBrk="1" latinLnBrk="0" hangingPunct="1">
       <a:defRPr sz="1200" kern="1200">
         <a:solidFill>
           <a:schemeClr val="tx1"/>
@@ -390,7 +184,7 @@
         <a:cs typeface="+mn-cs"/>
       </a:defRPr>
     </a:lvl2pPr>
-    <a:lvl3pPr marL="914400" algn="l" defTabSz="457200" rtl="0" eaLnBrk="1" latinLnBrk="0" hangingPunct="1">
+    <a:lvl3pPr marL="914400" algn="l" defTabSz="914400" rtl="0" eaLnBrk="1" latinLnBrk="0" hangingPunct="1">
       <a:defRPr sz="1200" kern="1200">
         <a:solidFill>
           <a:schemeClr val="tx1"/>
@@ -400,7 +194,7 @@
         <a:cs typeface="+mn-cs"/>
       </a:defRPr>
     </a:lvl3pPr>
-    <a:lvl4pPr marL="1371600" algn="l" defTabSz="457200" rtl="0" eaLnBrk="1" latinLnBrk="0" hangingPunct="1">
+    <a:lvl4pPr marL="1371600" algn="l" defTabSz="914400" rtl="0" eaLnBrk="1" latinLnBrk="0" hangingPunct="1">
       <a:defRPr sz="1200" kern="1200">
         <a:solidFill>
           <a:schemeClr val="tx1"/>
@@ -410,7 +204,7 @@
         <a:cs typeface="+mn-cs"/>
       </a:defRPr>
     </a:lvl4pPr>
-    <a:lvl5pPr marL="1828800" algn="l" defTabSz="457200" rtl="0" eaLnBrk="1" latinLnBrk="0" hangingPunct="1">
+    <a:lvl5pPr marL="1828800" algn="l" defTabSz="914400" rtl="0" eaLnBrk="1" latinLnBrk="0" hangingPunct="1">
       <a:defRPr sz="1200" kern="1200">
         <a:solidFill>
           <a:schemeClr val="tx1"/>
@@ -420,7 +214,7 @@
         <a:cs typeface="+mn-cs"/>
       </a:defRPr>
     </a:lvl5pPr>
-    <a:lvl6pPr marL="2286000" algn="l" defTabSz="457200" rtl="0" eaLnBrk="1" latinLnBrk="0" hangingPunct="1">
+    <a:lvl6pPr marL="2286000" algn="l" defTabSz="914400" rtl="0" eaLnBrk="1" latinLnBrk="0" hangingPunct="1">
       <a:defRPr sz="1200" kern="1200">
         <a:solidFill>
           <a:schemeClr val="tx1"/>
@@ -430,7 +224,7 @@
         <a:cs typeface="+mn-cs"/>
       </a:defRPr>
     </a:lvl6pPr>
-    <a:lvl7pPr marL="2743200" algn="l" defTabSz="457200" rtl="0" eaLnBrk="1" latinLnBrk="0" hangingPunct="1">
+    <a:lvl7pPr marL="2743200" algn="l" defTabSz="914400" rtl="0" eaLnBrk="1" latinLnBrk="0" hangingPunct="1">
       <a:defRPr sz="1200" kern="1200">
         <a:solidFill>
           <a:schemeClr val="tx1"/>
@@ -440,7 +234,7 @@
         <a:cs typeface="+mn-cs"/>
       </a:defRPr>
     </a:lvl7pPr>
-    <a:lvl8pPr marL="3200400" algn="l" defTabSz="457200" rtl="0" eaLnBrk="1" latinLnBrk="0" hangingPunct="1">
+    <a:lvl8pPr marL="3200400" algn="l" defTabSz="914400" rtl="0" eaLnBrk="1" latinLnBrk="0" hangingPunct="1">
       <a:defRPr sz="1200" kern="1200">
         <a:solidFill>
           <a:schemeClr val="tx1"/>
@@ -450,7 +244,7 @@
         <a:cs typeface="+mn-cs"/>
       </a:defRPr>
     </a:lvl8pPr>
-    <a:lvl9pPr marL="3657600" algn="l" defTabSz="457200" rtl="0" eaLnBrk="1" latinLnBrk="0" hangingPunct="1">
+    <a:lvl9pPr marL="3657600" algn="l" defTabSz="914400" rtl="0" eaLnBrk="1" latinLnBrk="0" hangingPunct="1">
       <a:defRPr sz="1200" kern="1200">
         <a:solidFill>
           <a:schemeClr val="tx1"/>
@@ -465,7 +259,7 @@
 </file>
 
 <file path=ppt/notesSlides/notesSlide1.xml><?xml version="1.0" encoding="utf-8"?>
-<p:notes xmlns:a="http://schemas.openxmlformats.org/drawingml/2006/main" xmlns:p="http://schemas.openxmlformats.org/presentationml/2006/main" xmlns:r="http://schemas.openxmlformats.org/officeDocument/2006/relationships">
+<p:notes xmlns:a="http://schemas.openxmlformats.org/drawingml/2006/main" xmlns:r="http://schemas.openxmlformats.org/officeDocument/2006/relationships" xmlns:p="http://schemas.openxmlformats.org/presentationml/2006/main">
   <p:cSld>
     <p:spTree>
       <p:nvGrpSpPr>
@@ -485,48 +279,48 @@
         <p:nvSpPr>
           <p:cNvPr id="2" name="Slide Image Placeholder 1"/>
           <p:cNvSpPr>
+            <a:spLocks noGrp="1" noRot="1" noChangeAspect="1"/>
+          </p:cNvSpPr>
+          <p:nvPr>
+            <p:ph type="sldImg" idx="2"/>
+          </p:nvPr>
+        </p:nvSpPr>
+        <p:spPr/>
+      </p:sp>
+      <p:sp>
+        <p:nvSpPr>
+          <p:cNvPr id="3" name="Notes Placeholder 2"/>
+          <p:cNvSpPr>
             <a:spLocks noGrp="1"/>
           </p:cNvSpPr>
           <p:nvPr>
-            <p:ph type="sldImg" idx="2"/>
+            <p:ph type="body" sz="quarter" idx="3"/>
           </p:nvPr>
         </p:nvSpPr>
         <p:spPr/>
-      </p:sp>
-      <p:sp>
-        <p:nvSpPr>
-          <p:cNvPr id="3" name="Notes Placeholder 2"/>
+        <p:txBody>
+          <a:bodyPr/>
+          <a:lstStyle/>
+          <a:p>
+            <a:r>
+              <a:t>SPEAKER SCRIPT (30s):</a:t>
+            </a:r>
+          </a:p>
+          <a:p>
+            <a:r>
+              <a:t>Hello judges! Today, we are presenting PawVibe — an innovative application that solves a real-world multi-billion dollar problem using Qloo’s Taste Intelligence API. While Qloo models cultural taste correlations across music, film, fashion, and places, PawVibe uses Qloo as a predictive 'Taste-to-Lifestyle' translation layer to match people with the right dog and cat breeds.</a:t>
+            </a:r>
+          </a:p>
+        </p:txBody>
+      </p:sp>
+      <p:sp>
+        <p:nvSpPr>
+          <p:cNvPr id="4" name="Slide Number Placeholder 3"/>
           <p:cNvSpPr>
             <a:spLocks noGrp="1"/>
           </p:cNvSpPr>
           <p:nvPr>
-            <p:ph type="body" idx="3" sz="quarter"/>
-          </p:nvPr>
-        </p:nvSpPr>
-        <p:spPr/>
-        <p:txBody>
-          <a:bodyPr/>
-          <a:lstStyle/>
-          <a:p>
-            <a:r>
-              <a:t>SPEAKER SCRIPT (30s):</a:t>
-            </a:r>
-          </a:p>
-          <a:p>
-            <a:r>
-              <a:t>Hello judges! Today, we are presenting PawVibe — an innovative application that solves a real-world multi-billion dollar problem using Qloo’s Taste Intelligence API. While Qloo models cultural taste correlations across music, film, fashion, and places, PawVibe uses Qloo as a predictive 'Taste-to-Lifestyle' translation layer to match people with the right dog and cat breeds.</a:t>
-            </a:r>
-          </a:p>
-        </p:txBody>
-      </p:sp>
-      <p:sp>
-        <p:nvSpPr>
-          <p:cNvPr id="4" name="Slide Number Placeholder 3"/>
-          <p:cNvSpPr>
-            <a:spLocks noGrp="1"/>
-          </p:cNvSpPr>
-          <p:nvPr>
-            <p:ph type="sldNum" idx="5" sz="quarter"/>
+            <p:ph type="sldNum" sz="quarter" idx="5"/>
           </p:nvPr>
         </p:nvSpPr>
         <p:spPr/>
@@ -540,7 +334,7 @@
 </file>
 
 <file path=ppt/notesSlides/notesSlide2.xml><?xml version="1.0" encoding="utf-8"?>
-<p:notes xmlns:a="http://schemas.openxmlformats.org/drawingml/2006/main" xmlns:p="http://schemas.openxmlformats.org/presentationml/2006/main" xmlns:r="http://schemas.openxmlformats.org/officeDocument/2006/relationships">
+<p:notes xmlns:a="http://schemas.openxmlformats.org/drawingml/2006/main" xmlns:r="http://schemas.openxmlformats.org/officeDocument/2006/relationships" xmlns:p="http://schemas.openxmlformats.org/presentationml/2006/main">
   <p:cSld>
     <p:spTree>
       <p:nvGrpSpPr>
@@ -560,48 +354,48 @@
         <p:nvSpPr>
           <p:cNvPr id="2" name="Slide Image Placeholder 1"/>
           <p:cNvSpPr>
+            <a:spLocks noGrp="1" noRot="1" noChangeAspect="1"/>
+          </p:cNvSpPr>
+          <p:nvPr>
+            <p:ph type="sldImg" idx="2"/>
+          </p:nvPr>
+        </p:nvSpPr>
+        <p:spPr/>
+      </p:sp>
+      <p:sp>
+        <p:nvSpPr>
+          <p:cNvPr id="3" name="Notes Placeholder 2"/>
+          <p:cNvSpPr>
             <a:spLocks noGrp="1"/>
           </p:cNvSpPr>
           <p:nvPr>
-            <p:ph type="sldImg" idx="2"/>
+            <p:ph type="body" sz="quarter" idx="3"/>
           </p:nvPr>
         </p:nvSpPr>
         <p:spPr/>
-      </p:sp>
-      <p:sp>
-        <p:nvSpPr>
-          <p:cNvPr id="3" name="Notes Placeholder 2"/>
+        <p:txBody>
+          <a:bodyPr/>
+          <a:lstStyle/>
+          <a:p>
+            <a:r>
+              <a:t>SPEAKER SCRIPT (45s):</a:t>
+            </a:r>
+          </a:p>
+          <a:p>
+            <a:r>
+              <a:t>Every year, 6.5 million companion animals enter shelters. Almost half of surrenders happen because owners pick pets based on looks rather than daily lifestyle compatibility. A remote worker in a studio adopts a high-drive working dog, or an endurance athlete adopts a sedentary cat. People cannot objectively calculate their lifestyle metrics in a boring questionnaire, but they know their favorite bands, films, and brands. That is where Qloo comes in.</a:t>
+            </a:r>
+          </a:p>
+        </p:txBody>
+      </p:sp>
+      <p:sp>
+        <p:nvSpPr>
+          <p:cNvPr id="4" name="Slide Number Placeholder 3"/>
           <p:cNvSpPr>
             <a:spLocks noGrp="1"/>
           </p:cNvSpPr>
           <p:nvPr>
-            <p:ph type="body" idx="3" sz="quarter"/>
-          </p:nvPr>
-        </p:nvSpPr>
-        <p:spPr/>
-        <p:txBody>
-          <a:bodyPr/>
-          <a:lstStyle/>
-          <a:p>
-            <a:r>
-              <a:t>SPEAKER SCRIPT (45s):</a:t>
-            </a:r>
-          </a:p>
-          <a:p>
-            <a:r>
-              <a:t>Every year, 6.5 million companion animals enter shelters. Almost half of surrenders happen because owners pick pets based on looks rather than daily lifestyle compatibility. A remote worker in a studio adopts a high-drive working dog, or an endurance athlete adopts a sedentary cat. People cannot objectively calculate their lifestyle metrics in a boring questionnaire, but they know their favorite bands, films, and brands. That is where Qloo comes in.</a:t>
-            </a:r>
-          </a:p>
-        </p:txBody>
-      </p:sp>
-      <p:sp>
-        <p:nvSpPr>
-          <p:cNvPr id="4" name="Slide Number Placeholder 3"/>
-          <p:cNvSpPr>
-            <a:spLocks noGrp="1"/>
-          </p:cNvSpPr>
-          <p:nvPr>
-            <p:ph type="sldNum" idx="5" sz="quarter"/>
+            <p:ph type="sldNum" sz="quarter" idx="5"/>
           </p:nvPr>
         </p:nvSpPr>
         <p:spPr/>
@@ -615,7 +409,7 @@
 </file>
 
 <file path=ppt/notesSlides/notesSlide3.xml><?xml version="1.0" encoding="utf-8"?>
-<p:notes xmlns:a="http://schemas.openxmlformats.org/drawingml/2006/main" xmlns:p="http://schemas.openxmlformats.org/presentationml/2006/main" xmlns:r="http://schemas.openxmlformats.org/officeDocument/2006/relationships">
+<p:notes xmlns:a="http://schemas.openxmlformats.org/drawingml/2006/main" xmlns:r="http://schemas.openxmlformats.org/officeDocument/2006/relationships" xmlns:p="http://schemas.openxmlformats.org/presentationml/2006/main">
   <p:cSld>
     <p:spTree>
       <p:nvGrpSpPr>
@@ -635,48 +429,48 @@
         <p:nvSpPr>
           <p:cNvPr id="2" name="Slide Image Placeholder 1"/>
           <p:cNvSpPr>
+            <a:spLocks noGrp="1" noRot="1" noChangeAspect="1"/>
+          </p:cNvSpPr>
+          <p:nvPr>
+            <p:ph type="sldImg" idx="2"/>
+          </p:nvPr>
+        </p:nvSpPr>
+        <p:spPr/>
+      </p:sp>
+      <p:sp>
+        <p:nvSpPr>
+          <p:cNvPr id="3" name="Notes Placeholder 2"/>
+          <p:cNvSpPr>
             <a:spLocks noGrp="1"/>
           </p:cNvSpPr>
           <p:nvPr>
-            <p:ph type="sldImg" idx="2"/>
+            <p:ph type="body" sz="quarter" idx="3"/>
           </p:nvPr>
         </p:nvSpPr>
         <p:spPr/>
-      </p:sp>
-      <p:sp>
-        <p:nvSpPr>
-          <p:cNvPr id="3" name="Notes Placeholder 2"/>
+        <p:txBody>
+          <a:bodyPr/>
+          <a:lstStyle/>
+          <a:p>
+            <a:r>
+              <a:t>SPEAKER SCRIPT (45s):</a:t>
+            </a:r>
+          </a:p>
+          <a:p>
+            <a:r>
+              <a:t>Qloo doesn't have a 'dog breeds' endpoint. But what Qloo DOES have is the world's most sophisticated cultural correlation graph. When a user likes Radiohead, A24 movies, and trail running, Qloo's Insights API tells us what places they visit and what brands they buy. PawVibe ingests these cultural correlations and synthesizes a calibrated 5D Lifestyle Vector, which we then mathematically match against canine and feline breed traits.</a:t>
+            </a:r>
+          </a:p>
+        </p:txBody>
+      </p:sp>
+      <p:sp>
+        <p:nvSpPr>
+          <p:cNvPr id="4" name="Slide Number Placeholder 3"/>
           <p:cNvSpPr>
             <a:spLocks noGrp="1"/>
           </p:cNvSpPr>
           <p:nvPr>
-            <p:ph type="body" idx="3" sz="quarter"/>
-          </p:nvPr>
-        </p:nvSpPr>
-        <p:spPr/>
-        <p:txBody>
-          <a:bodyPr/>
-          <a:lstStyle/>
-          <a:p>
-            <a:r>
-              <a:t>SPEAKER SCRIPT (45s):</a:t>
-            </a:r>
-          </a:p>
-          <a:p>
-            <a:r>
-              <a:t>Qloo doesn't have a 'dog breeds' endpoint. But what Qloo DOES have is the world's most sophisticated cultural correlation graph. When a user likes Radiohead, A24 movies, and trail running, Qloo's Insights API tells us what places they visit and what brands they buy. PawVibe ingests these cultural correlations and synthesizes a calibrated 5D Lifestyle Vector, which we then mathematically match against canine and feline breed traits.</a:t>
-            </a:r>
-          </a:p>
-        </p:txBody>
-      </p:sp>
-      <p:sp>
-        <p:nvSpPr>
-          <p:cNvPr id="4" name="Slide Number Placeholder 3"/>
-          <p:cNvSpPr>
-            <a:spLocks noGrp="1"/>
-          </p:cNvSpPr>
-          <p:nvPr>
-            <p:ph type="sldNum" idx="5" sz="quarter"/>
+            <p:ph type="sldNum" sz="quarter" idx="5"/>
           </p:nvPr>
         </p:nvSpPr>
         <p:spPr/>
@@ -690,7 +484,7 @@
 </file>
 
 <file path=ppt/notesSlides/notesSlide4.xml><?xml version="1.0" encoding="utf-8"?>
-<p:notes xmlns:a="http://schemas.openxmlformats.org/drawingml/2006/main" xmlns:p="http://schemas.openxmlformats.org/presentationml/2006/main" xmlns:r="http://schemas.openxmlformats.org/officeDocument/2006/relationships">
+<p:notes xmlns:a="http://schemas.openxmlformats.org/drawingml/2006/main" xmlns:r="http://schemas.openxmlformats.org/officeDocument/2006/relationships" xmlns:p="http://schemas.openxmlformats.org/presentationml/2006/main">
   <p:cSld>
     <p:spTree>
       <p:nvGrpSpPr>
@@ -710,48 +504,48 @@
         <p:nvSpPr>
           <p:cNvPr id="2" name="Slide Image Placeholder 1"/>
           <p:cNvSpPr>
+            <a:spLocks noGrp="1" noRot="1" noChangeAspect="1"/>
+          </p:cNvSpPr>
+          <p:nvPr>
+            <p:ph type="sldImg" idx="2"/>
+          </p:nvPr>
+        </p:nvSpPr>
+        <p:spPr/>
+      </p:sp>
+      <p:sp>
+        <p:nvSpPr>
+          <p:cNvPr id="3" name="Notes Placeholder 2"/>
+          <p:cNvSpPr>
             <a:spLocks noGrp="1"/>
           </p:cNvSpPr>
           <p:nvPr>
-            <p:ph type="sldImg" idx="2"/>
+            <p:ph type="body" sz="quarter" idx="3"/>
           </p:nvPr>
         </p:nvSpPr>
         <p:spPr/>
-      </p:sp>
-      <p:sp>
-        <p:nvSpPr>
-          <p:cNvPr id="3" name="Notes Placeholder 2"/>
+        <p:txBody>
+          <a:bodyPr/>
+          <a:lstStyle/>
+          <a:p>
+            <a:r>
+              <a:t>SPEAKER SCRIPT (40s):</a:t>
+            </a:r>
+          </a:p>
+          <a:p>
+            <a:r>
+              <a:t>Let's look under the hood. PawVibe is not a static prototype — it connects in real time to hackathon.api.qloo.com. First, we resolve cultural terms into Qloo entity IDs. Then, we query the Insights API for correlated places and brands. You can see in the screenshot right here: when the user enters creative tastes, Qloo extracts affinities like Blinkist and TED Talks, and places tagged as 'Tranquil' and 'Historic'. That live cultural context is directly injected into our matching vector.</a:t>
+            </a:r>
+          </a:p>
+        </p:txBody>
+      </p:sp>
+      <p:sp>
+        <p:nvSpPr>
+          <p:cNvPr id="4" name="Slide Number Placeholder 3"/>
           <p:cNvSpPr>
             <a:spLocks noGrp="1"/>
           </p:cNvSpPr>
           <p:nvPr>
-            <p:ph type="body" idx="3" sz="quarter"/>
-          </p:nvPr>
-        </p:nvSpPr>
-        <p:spPr/>
-        <p:txBody>
-          <a:bodyPr/>
-          <a:lstStyle/>
-          <a:p>
-            <a:r>
-              <a:t>SPEAKER SCRIPT (40s):</a:t>
-            </a:r>
-          </a:p>
-          <a:p>
-            <a:r>
-              <a:t>Let's look under the hood. PawVibe is not a static prototype — it connects in real time to hackathon.api.qloo.com. First, we resolve cultural terms into Qloo entity IDs. Then, we query the Insights API for correlated places and brands. You can see in the screenshot right here: when the user enters creative tastes, Qloo extracts affinities like Blinkist and TED Talks, and places tagged as 'Tranquil' and 'Historic'. That live cultural context is directly injected into our matching vector.</a:t>
-            </a:r>
-          </a:p>
-        </p:txBody>
-      </p:sp>
-      <p:sp>
-        <p:nvSpPr>
-          <p:cNvPr id="4" name="Slide Number Placeholder 3"/>
-          <p:cNvSpPr>
-            <a:spLocks noGrp="1"/>
-          </p:cNvSpPr>
-          <p:nvPr>
-            <p:ph type="sldNum" idx="5" sz="quarter"/>
+            <p:ph type="sldNum" sz="quarter" idx="5"/>
           </p:nvPr>
         </p:nvSpPr>
         <p:spPr/>
@@ -765,7 +559,7 @@
 </file>
 
 <file path=ppt/notesSlides/notesSlide5.xml><?xml version="1.0" encoding="utf-8"?>
-<p:notes xmlns:a="http://schemas.openxmlformats.org/drawingml/2006/main" xmlns:p="http://schemas.openxmlformats.org/presentationml/2006/main" xmlns:r="http://schemas.openxmlformats.org/officeDocument/2006/relationships">
+<p:notes xmlns:a="http://schemas.openxmlformats.org/drawingml/2006/main" xmlns:r="http://schemas.openxmlformats.org/officeDocument/2006/relationships" xmlns:p="http://schemas.openxmlformats.org/presentationml/2006/main">
   <p:cSld>
     <p:spTree>
       <p:nvGrpSpPr>
@@ -785,48 +579,48 @@
         <p:nvSpPr>
           <p:cNvPr id="2" name="Slide Image Placeholder 1"/>
           <p:cNvSpPr>
+            <a:spLocks noGrp="1" noRot="1" noChangeAspect="1"/>
+          </p:cNvSpPr>
+          <p:nvPr>
+            <p:ph type="sldImg" idx="2"/>
+          </p:nvPr>
+        </p:nvSpPr>
+        <p:spPr/>
+      </p:sp>
+      <p:sp>
+        <p:nvSpPr>
+          <p:cNvPr id="3" name="Notes Placeholder 2"/>
+          <p:cNvSpPr>
             <a:spLocks noGrp="1"/>
           </p:cNvSpPr>
           <p:nvPr>
-            <p:ph type="sldImg" idx="2"/>
+            <p:ph type="body" sz="quarter" idx="3"/>
           </p:nvPr>
         </p:nvSpPr>
         <p:spPr/>
-      </p:sp>
-      <p:sp>
-        <p:nvSpPr>
-          <p:cNvPr id="3" name="Notes Placeholder 2"/>
+        <p:txBody>
+          <a:bodyPr/>
+          <a:lstStyle/>
+          <a:p>
+            <a:r>
+              <a:t>SPEAKER SCRIPT (40s):</a:t>
+            </a:r>
+          </a:p>
+          <a:p>
+            <a:r>
+              <a:t>We don't use arbitrary keyword matching. We use a formal mathematical distance model. We weight Activity and Living Space slightly higher because animal welfare is most at risk when an active pet is confined in a small space. The engine computes weighted Euclidean distance across the 5 dimensions, calculates a normalized compatibility score, and isolates the exact trait overlaps to provide clear, explainable AI justifications.</a:t>
+            </a:r>
+          </a:p>
+        </p:txBody>
+      </p:sp>
+      <p:sp>
+        <p:nvSpPr>
+          <p:cNvPr id="4" name="Slide Number Placeholder 3"/>
           <p:cNvSpPr>
             <a:spLocks noGrp="1"/>
           </p:cNvSpPr>
           <p:nvPr>
-            <p:ph type="body" idx="3" sz="quarter"/>
-          </p:nvPr>
-        </p:nvSpPr>
-        <p:spPr/>
-        <p:txBody>
-          <a:bodyPr/>
-          <a:lstStyle/>
-          <a:p>
-            <a:r>
-              <a:t>SPEAKER SCRIPT (40s):</a:t>
-            </a:r>
-          </a:p>
-          <a:p>
-            <a:r>
-              <a:t>We don't use arbitrary keyword matching. We use a formal mathematical distance model. We weight Activity and Living Space slightly higher because animal welfare is most at risk when an active pet is confined in a small space. The engine computes weighted Euclidean distance across the 5 dimensions, calculates a normalized compatibility score, and isolates the exact trait overlaps to provide clear, explainable AI justifications.</a:t>
-            </a:r>
-          </a:p>
-        </p:txBody>
-      </p:sp>
-      <p:sp>
-        <p:nvSpPr>
-          <p:cNvPr id="4" name="Slide Number Placeholder 3"/>
-          <p:cNvSpPr>
-            <a:spLocks noGrp="1"/>
-          </p:cNvSpPr>
-          <p:nvPr>
-            <p:ph type="sldNum" idx="5" sz="quarter"/>
+            <p:ph type="sldNum" sz="quarter" idx="5"/>
           </p:nvPr>
         </p:nvSpPr>
         <p:spPr/>
@@ -840,7 +634,7 @@
 </file>
 
 <file path=ppt/notesSlides/notesSlide6.xml><?xml version="1.0" encoding="utf-8"?>
-<p:notes xmlns:a="http://schemas.openxmlformats.org/drawingml/2006/main" xmlns:p="http://schemas.openxmlformats.org/presentationml/2006/main" xmlns:r="http://schemas.openxmlformats.org/officeDocument/2006/relationships">
+<p:notes xmlns:a="http://schemas.openxmlformats.org/drawingml/2006/main" xmlns:r="http://schemas.openxmlformats.org/officeDocument/2006/relationships" xmlns:p="http://schemas.openxmlformats.org/presentationml/2006/main">
   <p:cSld>
     <p:spTree>
       <p:nvGrpSpPr>
@@ -860,48 +654,48 @@
         <p:nvSpPr>
           <p:cNvPr id="2" name="Slide Image Placeholder 1"/>
           <p:cNvSpPr>
+            <a:spLocks noGrp="1" noRot="1" noChangeAspect="1"/>
+          </p:cNvSpPr>
+          <p:nvPr>
+            <p:ph type="sldImg" idx="2"/>
+          </p:nvPr>
+        </p:nvSpPr>
+        <p:spPr/>
+      </p:sp>
+      <p:sp>
+        <p:nvSpPr>
+          <p:cNvPr id="3" name="Notes Placeholder 2"/>
+          <p:cNvSpPr>
             <a:spLocks noGrp="1"/>
           </p:cNvSpPr>
           <p:nvPr>
-            <p:ph type="sldImg" idx="2"/>
+            <p:ph type="body" sz="quarter" idx="3"/>
           </p:nvPr>
         </p:nvSpPr>
         <p:spPr/>
-      </p:sp>
-      <p:sp>
-        <p:nvSpPr>
-          <p:cNvPr id="3" name="Notes Placeholder 2"/>
+        <p:txBody>
+          <a:bodyPr/>
+          <a:lstStyle/>
+          <a:p>
+            <a:r>
+              <a:t>SPEAKER SCRIPT (35s):</a:t>
+            </a:r>
+          </a:p>
+          <a:p>
+            <a:r>
+              <a:t>Here is the user experience. We designed PawVibe with an editorial, high-end aesthetic inspired by luxury lifestyle magazines. Notice the flat SVG icons, warm beige canvas, and verified high-resolution photography. Each recommendation box features an interactive HTML5 Canvas radar chart overlaying the user's lifestyle vector in gold against the breed's required traits in charcoal grey, giving prospective owners an instant visual comparison.</a:t>
+            </a:r>
+          </a:p>
+        </p:txBody>
+      </p:sp>
+      <p:sp>
+        <p:nvSpPr>
+          <p:cNvPr id="4" name="Slide Number Placeholder 3"/>
           <p:cNvSpPr>
             <a:spLocks noGrp="1"/>
           </p:cNvSpPr>
           <p:nvPr>
-            <p:ph type="body" idx="3" sz="quarter"/>
-          </p:nvPr>
-        </p:nvSpPr>
-        <p:spPr/>
-        <p:txBody>
-          <a:bodyPr/>
-          <a:lstStyle/>
-          <a:p>
-            <a:r>
-              <a:t>SPEAKER SCRIPT (35s):</a:t>
-            </a:r>
-          </a:p>
-          <a:p>
-            <a:r>
-              <a:t>Here is the user experience. We designed PawVibe with an editorial, high-end aesthetic inspired by luxury lifestyle magazines. Notice the flat SVG icons, warm beige canvas, and verified high-resolution photography. Each recommendation box features an interactive HTML5 Canvas radar chart overlaying the user's lifestyle vector in gold against the breed's required traits in charcoal grey, giving prospective owners an instant visual comparison.</a:t>
-            </a:r>
-          </a:p>
-        </p:txBody>
-      </p:sp>
-      <p:sp>
-        <p:nvSpPr>
-          <p:cNvPr id="4" name="Slide Number Placeholder 3"/>
-          <p:cNvSpPr>
-            <a:spLocks noGrp="1"/>
-          </p:cNvSpPr>
-          <p:nvPr>
-            <p:ph type="sldNum" idx="5" sz="quarter"/>
+            <p:ph type="sldNum" sz="quarter" idx="5"/>
           </p:nvPr>
         </p:nvSpPr>
         <p:spPr/>
@@ -915,7 +709,7 @@
 </file>
 
 <file path=ppt/notesSlides/notesSlide7.xml><?xml version="1.0" encoding="utf-8"?>
-<p:notes xmlns:a="http://schemas.openxmlformats.org/drawingml/2006/main" xmlns:p="http://schemas.openxmlformats.org/presentationml/2006/main" xmlns:r="http://schemas.openxmlformats.org/officeDocument/2006/relationships">
+<p:notes xmlns:a="http://schemas.openxmlformats.org/drawingml/2006/main" xmlns:r="http://schemas.openxmlformats.org/officeDocument/2006/relationships" xmlns:p="http://schemas.openxmlformats.org/presentationml/2006/main">
   <p:cSld>
     <p:spTree>
       <p:nvGrpSpPr>
@@ -935,48 +729,48 @@
         <p:nvSpPr>
           <p:cNvPr id="2" name="Slide Image Placeholder 1"/>
           <p:cNvSpPr>
+            <a:spLocks noGrp="1" noRot="1" noChangeAspect="1"/>
+          </p:cNvSpPr>
+          <p:nvPr>
+            <p:ph type="sldImg" idx="2"/>
+          </p:nvPr>
+        </p:nvSpPr>
+        <p:spPr/>
+      </p:sp>
+      <p:sp>
+        <p:nvSpPr>
+          <p:cNvPr id="3" name="Notes Placeholder 2"/>
+          <p:cNvSpPr>
             <a:spLocks noGrp="1"/>
           </p:cNvSpPr>
           <p:nvPr>
-            <p:ph type="sldImg" idx="2"/>
+            <p:ph type="body" sz="quarter" idx="3"/>
           </p:nvPr>
         </p:nvSpPr>
         <p:spPr/>
-      </p:sp>
-      <p:sp>
-        <p:nvSpPr>
-          <p:cNvPr id="3" name="Notes Placeholder 2"/>
+        <p:txBody>
+          <a:bodyPr/>
+          <a:lstStyle/>
+          <a:p>
+            <a:r>
+              <a:t>SPEAKER SCRIPT (40s):</a:t>
+            </a:r>
+          </a:p>
+          <a:p>
+            <a:r>
+              <a:t>The pet economy is a $150 billion dollar market. But beyond the commercial opportunity, PawVibe has immense social impact. Because we ingest Qloo brand affinities, we can also recommend personalized gear, food subscriptions, and pet insurance. And by preventing incompatible adoptions before they happen, we keep animals in loving homes and out of shelters.</a:t>
+            </a:r>
+          </a:p>
+        </p:txBody>
+      </p:sp>
+      <p:sp>
+        <p:nvSpPr>
+          <p:cNvPr id="4" name="Slide Number Placeholder 3"/>
           <p:cNvSpPr>
             <a:spLocks noGrp="1"/>
           </p:cNvSpPr>
           <p:nvPr>
-            <p:ph type="body" idx="3" sz="quarter"/>
-          </p:nvPr>
-        </p:nvSpPr>
-        <p:spPr/>
-        <p:txBody>
-          <a:bodyPr/>
-          <a:lstStyle/>
-          <a:p>
-            <a:r>
-              <a:t>SPEAKER SCRIPT (40s):</a:t>
-            </a:r>
-          </a:p>
-          <a:p>
-            <a:r>
-              <a:t>The pet economy is a $150 billion dollar market. But beyond the commercial opportunity, PawVibe has immense social impact. Because we ingest Qloo brand affinities, we can also recommend personalized gear, food subscriptions, and pet insurance. And by preventing incompatible adoptions before they happen, we keep animals in loving homes and out of shelters.</a:t>
-            </a:r>
-          </a:p>
-        </p:txBody>
-      </p:sp>
-      <p:sp>
-        <p:nvSpPr>
-          <p:cNvPr id="4" name="Slide Number Placeholder 3"/>
-          <p:cNvSpPr>
-            <a:spLocks noGrp="1"/>
-          </p:cNvSpPr>
-          <p:nvPr>
-            <p:ph type="sldNum" idx="5" sz="quarter"/>
+            <p:ph type="sldNum" sz="quarter" idx="5"/>
           </p:nvPr>
         </p:nvSpPr>
         <p:spPr/>
@@ -990,7 +784,7 @@
 </file>
 
 <file path=ppt/notesSlides/notesSlide8.xml><?xml version="1.0" encoding="utf-8"?>
-<p:notes xmlns:a="http://schemas.openxmlformats.org/drawingml/2006/main" xmlns:p="http://schemas.openxmlformats.org/presentationml/2006/main" xmlns:r="http://schemas.openxmlformats.org/officeDocument/2006/relationships">
+<p:notes xmlns:a="http://schemas.openxmlformats.org/drawingml/2006/main" xmlns:r="http://schemas.openxmlformats.org/officeDocument/2006/relationships" xmlns:p="http://schemas.openxmlformats.org/presentationml/2006/main">
   <p:cSld>
     <p:spTree>
       <p:nvGrpSpPr>
@@ -1010,48 +804,48 @@
         <p:nvSpPr>
           <p:cNvPr id="2" name="Slide Image Placeholder 1"/>
           <p:cNvSpPr>
+            <a:spLocks noGrp="1" noRot="1" noChangeAspect="1"/>
+          </p:cNvSpPr>
+          <p:nvPr>
+            <p:ph type="sldImg" idx="2"/>
+          </p:nvPr>
+        </p:nvSpPr>
+        <p:spPr/>
+      </p:sp>
+      <p:sp>
+        <p:nvSpPr>
+          <p:cNvPr id="3" name="Notes Placeholder 2"/>
+          <p:cNvSpPr>
             <a:spLocks noGrp="1"/>
           </p:cNvSpPr>
           <p:nvPr>
-            <p:ph type="sldImg" idx="2"/>
+            <p:ph type="body" sz="quarter" idx="3"/>
           </p:nvPr>
         </p:nvSpPr>
         <p:spPr/>
-      </p:sp>
-      <p:sp>
-        <p:nvSpPr>
-          <p:cNvPr id="3" name="Notes Placeholder 2"/>
+        <p:txBody>
+          <a:bodyPr/>
+          <a:lstStyle/>
+          <a:p>
+            <a:r>
+              <a:t>SPEAKER SCRIPT (30s):</a:t>
+            </a:r>
+          </a:p>
+          <a:p>
+            <a:r>
+              <a:t>To wrap up: PawVibe stands out because it takes Qloo into a completely fresh, high-impact vertical. It is fully functional, beautifully designed, and connected to the live Qloo Hackathon API. Thank you so much, and we'd love to take any questions or show you a live demo!</a:t>
+            </a:r>
+          </a:p>
+        </p:txBody>
+      </p:sp>
+      <p:sp>
+        <p:nvSpPr>
+          <p:cNvPr id="4" name="Slide Number Placeholder 3"/>
           <p:cNvSpPr>
             <a:spLocks noGrp="1"/>
           </p:cNvSpPr>
           <p:nvPr>
-            <p:ph type="body" idx="3" sz="quarter"/>
-          </p:nvPr>
-        </p:nvSpPr>
-        <p:spPr/>
-        <p:txBody>
-          <a:bodyPr/>
-          <a:lstStyle/>
-          <a:p>
-            <a:r>
-              <a:t>SPEAKER SCRIPT (30s):</a:t>
-            </a:r>
-          </a:p>
-          <a:p>
-            <a:r>
-              <a:t>To wrap up: PawVibe stands out because it takes Qloo into a completely fresh, high-impact vertical. It is fully functional, beautifully designed, and connected to the live Qloo Hackathon API. Thank you so much, and we'd love to take any questions or show you a live demo!</a:t>
-            </a:r>
-          </a:p>
-        </p:txBody>
-      </p:sp>
-      <p:sp>
-        <p:nvSpPr>
-          <p:cNvPr id="4" name="Slide Number Placeholder 3"/>
-          <p:cNvSpPr>
-            <a:spLocks noGrp="1"/>
-          </p:cNvSpPr>
-          <p:nvPr>
-            <p:ph type="sldNum" idx="5" sz="quarter"/>
+            <p:ph type="sldNum" sz="quarter" idx="5"/>
           </p:nvPr>
         </p:nvSpPr>
         <p:spPr/>
@@ -1102,10 +896,9 @@
           <a:lstStyle/>
           <a:p>
             <a:r>
-              <a:rPr lang="en-US" smtClean="0"/>
+              <a:rPr lang="en-US"/>
               <a:t>Click to edit Master title style</a:t>
             </a:r>
-            <a:endParaRPr lang="en-US"/>
           </a:p>
         </p:txBody>
       </p:sp>
@@ -1221,10 +1014,9 @@
           </a:lstStyle>
           <a:p>
             <a:r>
-              <a:rPr lang="en-US" smtClean="0"/>
+              <a:rPr lang="en-US"/>
               <a:t>Click to edit Master subtitle style</a:t>
             </a:r>
-            <a:endParaRPr lang="en-US"/>
           </a:p>
         </p:txBody>
       </p:sp>
@@ -1245,7 +1037,7 @@
           <a:p>
             <a:fld id="{5BCAD085-E8A6-8845-BD4E-CB4CCA059FC4}" type="datetimeFigureOut">
               <a:rPr lang="en-US" smtClean="0"/>
-              <a:t>1/27/13</a:t>
+              <a:t>10/28/2026</a:t>
             </a:fld>
             <a:endParaRPr lang="en-US"/>
           </a:p>
@@ -1339,10 +1131,9 @@
           <a:lstStyle/>
           <a:p>
             <a:r>
-              <a:rPr lang="en-US" smtClean="0"/>
+              <a:rPr lang="en-US"/>
               <a:t>Click to edit Master title style</a:t>
             </a:r>
-            <a:endParaRPr lang="en-US"/>
           </a:p>
         </p:txBody>
       </p:sp>
@@ -1363,38 +1154,37 @@
           <a:p>
             <a:pPr lvl="0"/>
             <a:r>
-              <a:rPr lang="en-US" smtClean="0"/>
+              <a:rPr lang="en-US"/>
               <a:t>Click to edit Master text styles</a:t>
             </a:r>
           </a:p>
           <a:p>
             <a:pPr lvl="1"/>
             <a:r>
-              <a:rPr lang="en-US" smtClean="0"/>
+              <a:rPr lang="en-US"/>
               <a:t>Second level</a:t>
             </a:r>
           </a:p>
           <a:p>
             <a:pPr lvl="2"/>
             <a:r>
-              <a:rPr lang="en-US" smtClean="0"/>
+              <a:rPr lang="en-US"/>
               <a:t>Third level</a:t>
             </a:r>
           </a:p>
           <a:p>
             <a:pPr lvl="3"/>
             <a:r>
-              <a:rPr lang="en-US" smtClean="0"/>
+              <a:rPr lang="en-US"/>
               <a:t>Fourth level</a:t>
             </a:r>
           </a:p>
           <a:p>
             <a:pPr lvl="4"/>
             <a:r>
-              <a:rPr lang="en-US" smtClean="0"/>
+              <a:rPr lang="en-US"/>
               <a:t>Fifth level</a:t>
             </a:r>
-            <a:endParaRPr lang="en-US"/>
           </a:p>
         </p:txBody>
       </p:sp>
@@ -1415,7 +1205,7 @@
           <a:p>
             <a:fld id="{5BCAD085-E8A6-8845-BD4E-CB4CCA059FC4}" type="datetimeFigureOut">
               <a:rPr lang="en-US" smtClean="0"/>
-              <a:t>1/27/13</a:t>
+              <a:t>10/28/2026</a:t>
             </a:fld>
             <a:endParaRPr lang="en-US"/>
           </a:p>
@@ -1514,10 +1304,9 @@
           <a:lstStyle/>
           <a:p>
             <a:r>
-              <a:rPr lang="en-US" smtClean="0"/>
+              <a:rPr lang="en-US"/>
               <a:t>Click to edit Master title style</a:t>
             </a:r>
-            <a:endParaRPr lang="en-US"/>
           </a:p>
         </p:txBody>
       </p:sp>
@@ -1543,38 +1332,37 @@
           <a:p>
             <a:pPr lvl="0"/>
             <a:r>
-              <a:rPr lang="en-US" smtClean="0"/>
+              <a:rPr lang="en-US"/>
               <a:t>Click to edit Master text styles</a:t>
             </a:r>
           </a:p>
           <a:p>
             <a:pPr lvl="1"/>
             <a:r>
-              <a:rPr lang="en-US" smtClean="0"/>
+              <a:rPr lang="en-US"/>
               <a:t>Second level</a:t>
             </a:r>
           </a:p>
           <a:p>
             <a:pPr lvl="2"/>
             <a:r>
-              <a:rPr lang="en-US" smtClean="0"/>
+              <a:rPr lang="en-US"/>
               <a:t>Third level</a:t>
             </a:r>
           </a:p>
           <a:p>
             <a:pPr lvl="3"/>
             <a:r>
-              <a:rPr lang="en-US" smtClean="0"/>
+              <a:rPr lang="en-US"/>
               <a:t>Fourth level</a:t>
             </a:r>
           </a:p>
           <a:p>
             <a:pPr lvl="4"/>
             <a:r>
-              <a:rPr lang="en-US" smtClean="0"/>
+              <a:rPr lang="en-US"/>
               <a:t>Fifth level</a:t>
             </a:r>
-            <a:endParaRPr lang="en-US"/>
           </a:p>
         </p:txBody>
       </p:sp>
@@ -1595,7 +1383,7 @@
           <a:p>
             <a:fld id="{5BCAD085-E8A6-8845-BD4E-CB4CCA059FC4}" type="datetimeFigureOut">
               <a:rPr lang="en-US" smtClean="0"/>
-              <a:t>1/27/13</a:t>
+              <a:t>10/28/2026</a:t>
             </a:fld>
             <a:endParaRPr lang="en-US"/>
           </a:p>
@@ -1689,10 +1477,9 @@
           <a:lstStyle/>
           <a:p>
             <a:r>
-              <a:rPr lang="en-US" smtClean="0"/>
+              <a:rPr lang="en-US"/>
               <a:t>Click to edit Master title style</a:t>
             </a:r>
-            <a:endParaRPr lang="en-US"/>
           </a:p>
         </p:txBody>
       </p:sp>
@@ -1713,38 +1500,37 @@
           <a:p>
             <a:pPr lvl="0"/>
             <a:r>
-              <a:rPr lang="en-US" smtClean="0"/>
+              <a:rPr lang="en-US"/>
               <a:t>Click to edit Master text styles</a:t>
             </a:r>
           </a:p>
           <a:p>
             <a:pPr lvl="1"/>
             <a:r>
-              <a:rPr lang="en-US" smtClean="0"/>
+              <a:rPr lang="en-US"/>
               <a:t>Second level</a:t>
             </a:r>
           </a:p>
           <a:p>
             <a:pPr lvl="2"/>
             <a:r>
-              <a:rPr lang="en-US" smtClean="0"/>
+              <a:rPr lang="en-US"/>
               <a:t>Third level</a:t>
             </a:r>
           </a:p>
           <a:p>
             <a:pPr lvl="3"/>
             <a:r>
-              <a:rPr lang="en-US" smtClean="0"/>
+              <a:rPr lang="en-US"/>
               <a:t>Fourth level</a:t>
             </a:r>
           </a:p>
           <a:p>
             <a:pPr lvl="4"/>
             <a:r>
-              <a:rPr lang="en-US" smtClean="0"/>
+              <a:rPr lang="en-US"/>
               <a:t>Fifth level</a:t>
             </a:r>
-            <a:endParaRPr lang="en-US"/>
           </a:p>
         </p:txBody>
       </p:sp>
@@ -1765,7 +1551,7 @@
           <a:p>
             <a:fld id="{5BCAD085-E8A6-8845-BD4E-CB4CCA059FC4}" type="datetimeFigureOut">
               <a:rPr lang="en-US" smtClean="0"/>
-              <a:t>1/27/13</a:t>
+              <a:t>10/28/2026</a:t>
             </a:fld>
             <a:endParaRPr lang="en-US"/>
           </a:p>
@@ -1868,10 +1654,9 @@
           </a:lstStyle>
           <a:p>
             <a:r>
-              <a:rPr lang="en-US" smtClean="0"/>
+              <a:rPr lang="en-US"/>
               <a:t>Click to edit Master title style</a:t>
             </a:r>
-            <a:endParaRPr lang="en-US"/>
           </a:p>
         </p:txBody>
       </p:sp>
@@ -1988,7 +1773,7 @@
           <a:p>
             <a:pPr lvl="0"/>
             <a:r>
-              <a:rPr lang="en-US" smtClean="0"/>
+              <a:rPr lang="en-US"/>
               <a:t>Click to edit Master text styles</a:t>
             </a:r>
           </a:p>
@@ -2011,7 +1796,7 @@
           <a:p>
             <a:fld id="{5BCAD085-E8A6-8845-BD4E-CB4CCA059FC4}" type="datetimeFigureOut">
               <a:rPr lang="en-US" smtClean="0"/>
-              <a:t>1/27/13</a:t>
+              <a:t>10/28/2026</a:t>
             </a:fld>
             <a:endParaRPr lang="en-US"/>
           </a:p>
@@ -2105,10 +1890,9 @@
           <a:lstStyle/>
           <a:p>
             <a:r>
-              <a:rPr lang="en-US" smtClean="0"/>
+              <a:rPr lang="en-US"/>
               <a:t>Click to edit Master title style</a:t>
             </a:r>
-            <a:endParaRPr lang="en-US"/>
           </a:p>
         </p:txBody>
       </p:sp>
@@ -2162,38 +1946,37 @@
           <a:p>
             <a:pPr lvl="0"/>
             <a:r>
-              <a:rPr lang="en-US" smtClean="0"/>
+              <a:rPr lang="en-US"/>
               <a:t>Click to edit Master text styles</a:t>
             </a:r>
           </a:p>
           <a:p>
             <a:pPr lvl="1"/>
             <a:r>
-              <a:rPr lang="en-US" smtClean="0"/>
+              <a:rPr lang="en-US"/>
               <a:t>Second level</a:t>
             </a:r>
           </a:p>
           <a:p>
             <a:pPr lvl="2"/>
             <a:r>
-              <a:rPr lang="en-US" smtClean="0"/>
+              <a:rPr lang="en-US"/>
               <a:t>Third level</a:t>
             </a:r>
           </a:p>
           <a:p>
             <a:pPr lvl="3"/>
             <a:r>
-              <a:rPr lang="en-US" smtClean="0"/>
+              <a:rPr lang="en-US"/>
               <a:t>Fourth level</a:t>
             </a:r>
           </a:p>
           <a:p>
             <a:pPr lvl="4"/>
             <a:r>
-              <a:rPr lang="en-US" smtClean="0"/>
+              <a:rPr lang="en-US"/>
               <a:t>Fifth level</a:t>
             </a:r>
-            <a:endParaRPr lang="en-US"/>
           </a:p>
         </p:txBody>
       </p:sp>
@@ -2247,38 +2030,37 @@
           <a:p>
             <a:pPr lvl="0"/>
             <a:r>
-              <a:rPr lang="en-US" smtClean="0"/>
+              <a:rPr lang="en-US"/>
               <a:t>Click to edit Master text styles</a:t>
             </a:r>
           </a:p>
           <a:p>
             <a:pPr lvl="1"/>
             <a:r>
-              <a:rPr lang="en-US" smtClean="0"/>
+              <a:rPr lang="en-US"/>
               <a:t>Second level</a:t>
             </a:r>
           </a:p>
           <a:p>
             <a:pPr lvl="2"/>
             <a:r>
-              <a:rPr lang="en-US" smtClean="0"/>
+              <a:rPr lang="en-US"/>
               <a:t>Third level</a:t>
             </a:r>
           </a:p>
           <a:p>
             <a:pPr lvl="3"/>
             <a:r>
-              <a:rPr lang="en-US" smtClean="0"/>
+              <a:rPr lang="en-US"/>
               <a:t>Fourth level</a:t>
             </a:r>
           </a:p>
           <a:p>
             <a:pPr lvl="4"/>
             <a:r>
-              <a:rPr lang="en-US" smtClean="0"/>
+              <a:rPr lang="en-US"/>
               <a:t>Fifth level</a:t>
             </a:r>
-            <a:endParaRPr lang="en-US"/>
           </a:p>
         </p:txBody>
       </p:sp>
@@ -2299,7 +2081,7 @@
           <a:p>
             <a:fld id="{5BCAD085-E8A6-8845-BD4E-CB4CCA059FC4}" type="datetimeFigureOut">
               <a:rPr lang="en-US" smtClean="0"/>
-              <a:t>1/27/13</a:t>
+              <a:t>10/28/2026</a:t>
             </a:fld>
             <a:endParaRPr lang="en-US"/>
           </a:p>
@@ -2397,10 +2179,9 @@
           </a:lstStyle>
           <a:p>
             <a:r>
-              <a:rPr lang="en-US" smtClean="0"/>
+              <a:rPr lang="en-US"/>
               <a:t>Click to edit Master title style</a:t>
             </a:r>
-            <a:endParaRPr lang="en-US"/>
           </a:p>
         </p:txBody>
       </p:sp>
@@ -2463,7 +2244,7 @@
           <a:p>
             <a:pPr lvl="0"/>
             <a:r>
-              <a:rPr lang="en-US" smtClean="0"/>
+              <a:rPr lang="en-US"/>
               <a:t>Click to edit Master text styles</a:t>
             </a:r>
           </a:p>
@@ -2519,38 +2300,37 @@
           <a:p>
             <a:pPr lvl="0"/>
             <a:r>
-              <a:rPr lang="en-US" smtClean="0"/>
+              <a:rPr lang="en-US"/>
               <a:t>Click to edit Master text styles</a:t>
             </a:r>
           </a:p>
           <a:p>
             <a:pPr lvl="1"/>
             <a:r>
-              <a:rPr lang="en-US" smtClean="0"/>
+              <a:rPr lang="en-US"/>
               <a:t>Second level</a:t>
             </a:r>
           </a:p>
           <a:p>
             <a:pPr lvl="2"/>
             <a:r>
-              <a:rPr lang="en-US" smtClean="0"/>
+              <a:rPr lang="en-US"/>
               <a:t>Third level</a:t>
             </a:r>
           </a:p>
           <a:p>
             <a:pPr lvl="3"/>
             <a:r>
-              <a:rPr lang="en-US" smtClean="0"/>
+              <a:rPr lang="en-US"/>
               <a:t>Fourth level</a:t>
             </a:r>
           </a:p>
           <a:p>
             <a:pPr lvl="4"/>
             <a:r>
-              <a:rPr lang="en-US" smtClean="0"/>
+              <a:rPr lang="en-US"/>
               <a:t>Fifth level</a:t>
             </a:r>
-            <a:endParaRPr lang="en-US"/>
           </a:p>
         </p:txBody>
       </p:sp>
@@ -2613,7 +2393,7 @@
           <a:p>
             <a:pPr lvl="0"/>
             <a:r>
-              <a:rPr lang="en-US" smtClean="0"/>
+              <a:rPr lang="en-US"/>
               <a:t>Click to edit Master text styles</a:t>
             </a:r>
           </a:p>
@@ -2669,38 +2449,37 @@
           <a:p>
             <a:pPr lvl="0"/>
             <a:r>
-              <a:rPr lang="en-US" smtClean="0"/>
+              <a:rPr lang="en-US"/>
               <a:t>Click to edit Master text styles</a:t>
             </a:r>
           </a:p>
           <a:p>
             <a:pPr lvl="1"/>
             <a:r>
-              <a:rPr lang="en-US" smtClean="0"/>
+              <a:rPr lang="en-US"/>
               <a:t>Second level</a:t>
             </a:r>
           </a:p>
           <a:p>
             <a:pPr lvl="2"/>
             <a:r>
-              <a:rPr lang="en-US" smtClean="0"/>
+              <a:rPr lang="en-US"/>
               <a:t>Third level</a:t>
             </a:r>
           </a:p>
           <a:p>
             <a:pPr lvl="3"/>
             <a:r>
-              <a:rPr lang="en-US" smtClean="0"/>
+              <a:rPr lang="en-US"/>
               <a:t>Fourth level</a:t>
             </a:r>
           </a:p>
           <a:p>
             <a:pPr lvl="4"/>
             <a:r>
-              <a:rPr lang="en-US" smtClean="0"/>
+              <a:rPr lang="en-US"/>
               <a:t>Fifth level</a:t>
             </a:r>
-            <a:endParaRPr lang="en-US"/>
           </a:p>
         </p:txBody>
       </p:sp>
@@ -2721,7 +2500,7 @@
           <a:p>
             <a:fld id="{5BCAD085-E8A6-8845-BD4E-CB4CCA059FC4}" type="datetimeFigureOut">
               <a:rPr lang="en-US" smtClean="0"/>
-              <a:t>1/27/13</a:t>
+              <a:t>10/28/2026</a:t>
             </a:fld>
             <a:endParaRPr lang="en-US"/>
           </a:p>
@@ -2815,10 +2594,9 @@
           <a:lstStyle/>
           <a:p>
             <a:r>
-              <a:rPr lang="en-US" smtClean="0"/>
+              <a:rPr lang="en-US"/>
               <a:t>Click to edit Master title style</a:t>
             </a:r>
-            <a:endParaRPr lang="en-US"/>
           </a:p>
         </p:txBody>
       </p:sp>
@@ -2839,7 +2617,7 @@
           <a:p>
             <a:fld id="{5BCAD085-E8A6-8845-BD4E-CB4CCA059FC4}" type="datetimeFigureOut">
               <a:rPr lang="en-US" smtClean="0"/>
-              <a:t>1/27/13</a:t>
+              <a:t>10/28/2026</a:t>
             </a:fld>
             <a:endParaRPr lang="en-US"/>
           </a:p>
@@ -2934,7 +2712,7 @@
           <a:p>
             <a:fld id="{5BCAD085-E8A6-8845-BD4E-CB4CCA059FC4}" type="datetimeFigureOut">
               <a:rPr lang="en-US" smtClean="0"/>
-              <a:t>1/27/13</a:t>
+              <a:t>10/28/2026</a:t>
             </a:fld>
             <a:endParaRPr lang="en-US"/>
           </a:p>
@@ -3037,10 +2815,9 @@
           </a:lstStyle>
           <a:p>
             <a:r>
-              <a:rPr lang="en-US" smtClean="0"/>
+              <a:rPr lang="en-US"/>
               <a:t>Click to edit Master title style</a:t>
             </a:r>
-            <a:endParaRPr lang="en-US"/>
           </a:p>
         </p:txBody>
       </p:sp>
@@ -3094,38 +2871,37 @@
           <a:p>
             <a:pPr lvl="0"/>
             <a:r>
-              <a:rPr lang="en-US" smtClean="0"/>
+              <a:rPr lang="en-US"/>
               <a:t>Click to edit Master text styles</a:t>
             </a:r>
           </a:p>
           <a:p>
             <a:pPr lvl="1"/>
             <a:r>
-              <a:rPr lang="en-US" smtClean="0"/>
+              <a:rPr lang="en-US"/>
               <a:t>Second level</a:t>
             </a:r>
           </a:p>
           <a:p>
             <a:pPr lvl="2"/>
             <a:r>
-              <a:rPr lang="en-US" smtClean="0"/>
+              <a:rPr lang="en-US"/>
               <a:t>Third level</a:t>
             </a:r>
           </a:p>
           <a:p>
             <a:pPr lvl="3"/>
             <a:r>
-              <a:rPr lang="en-US" smtClean="0"/>
+              <a:rPr lang="en-US"/>
               <a:t>Fourth level</a:t>
             </a:r>
           </a:p>
           <a:p>
             <a:pPr lvl="4"/>
             <a:r>
-              <a:rPr lang="en-US" smtClean="0"/>
+              <a:rPr lang="en-US"/>
               <a:t>Fifth level</a:t>
             </a:r>
-            <a:endParaRPr lang="en-US"/>
           </a:p>
         </p:txBody>
       </p:sp>
@@ -3188,7 +2964,7 @@
           <a:p>
             <a:pPr lvl="0"/>
             <a:r>
-              <a:rPr lang="en-US" smtClean="0"/>
+              <a:rPr lang="en-US"/>
               <a:t>Click to edit Master text styles</a:t>
             </a:r>
           </a:p>
@@ -3211,7 +2987,7 @@
           <a:p>
             <a:fld id="{5BCAD085-E8A6-8845-BD4E-CB4CCA059FC4}" type="datetimeFigureOut">
               <a:rPr lang="en-US" smtClean="0"/>
-              <a:t>1/27/13</a:t>
+              <a:t>10/28/2026</a:t>
             </a:fld>
             <a:endParaRPr lang="en-US"/>
           </a:p>
@@ -3314,10 +3090,9 @@
           </a:lstStyle>
           <a:p>
             <a:r>
-              <a:rPr lang="en-US" smtClean="0"/>
+              <a:rPr lang="en-US"/>
               <a:t>Click to edit Master title style</a:t>
             </a:r>
-            <a:endParaRPr lang="en-US"/>
           </a:p>
         </p:txBody>
       </p:sp>
@@ -3441,7 +3216,7 @@
           <a:p>
             <a:pPr lvl="0"/>
             <a:r>
-              <a:rPr lang="en-US" smtClean="0"/>
+              <a:rPr lang="en-US"/>
               <a:t>Click to edit Master text styles</a:t>
             </a:r>
           </a:p>
@@ -3464,7 +3239,7 @@
           <a:p>
             <a:fld id="{5BCAD085-E8A6-8845-BD4E-CB4CCA059FC4}" type="datetimeFigureOut">
               <a:rPr lang="en-US" smtClean="0"/>
-              <a:t>1/27/13</a:t>
+              <a:t>10/28/2026</a:t>
             </a:fld>
             <a:endParaRPr lang="en-US"/>
           </a:p>
@@ -3573,10 +3348,9 @@
           <a:lstStyle/>
           <a:p>
             <a:r>
-              <a:rPr lang="en-US" smtClean="0"/>
+              <a:rPr lang="en-US"/>
               <a:t>Click to edit Master title style</a:t>
             </a:r>
-            <a:endParaRPr lang="en-US"/>
           </a:p>
         </p:txBody>
       </p:sp>
@@ -3607,38 +3381,37 @@
           <a:p>
             <a:pPr lvl="0"/>
             <a:r>
-              <a:rPr lang="en-US" smtClean="0"/>
+              <a:rPr lang="en-US"/>
               <a:t>Click to edit Master text styles</a:t>
             </a:r>
           </a:p>
           <a:p>
             <a:pPr lvl="1"/>
             <a:r>
-              <a:rPr lang="en-US" smtClean="0"/>
+              <a:rPr lang="en-US"/>
               <a:t>Second level</a:t>
             </a:r>
           </a:p>
           <a:p>
             <a:pPr lvl="2"/>
             <a:r>
-              <a:rPr lang="en-US" smtClean="0"/>
+              <a:rPr lang="en-US"/>
               <a:t>Third level</a:t>
             </a:r>
           </a:p>
           <a:p>
             <a:pPr lvl="3"/>
             <a:r>
-              <a:rPr lang="en-US" smtClean="0"/>
+              <a:rPr lang="en-US"/>
               <a:t>Fourth level</a:t>
             </a:r>
           </a:p>
           <a:p>
             <a:pPr lvl="4"/>
             <a:r>
-              <a:rPr lang="en-US" smtClean="0"/>
+              <a:rPr lang="en-US"/>
               <a:t>Fifth level</a:t>
             </a:r>
-            <a:endParaRPr lang="en-US"/>
           </a:p>
         </p:txBody>
       </p:sp>
@@ -3677,7 +3450,7 @@
           <a:p>
             <a:fld id="{5BCAD085-E8A6-8845-BD4E-CB4CCA059FC4}" type="datetimeFigureOut">
               <a:rPr lang="en-US" smtClean="0"/>
-              <a:t>1/27/13</a:t>
+              <a:t>10/28/2026</a:t>
             </a:fld>
             <a:endParaRPr lang="en-US"/>
           </a:p>
@@ -4036,7 +3809,7 @@
 </file>
 
 <file path=ppt/slides/slide1.xml><?xml version="1.0" encoding="utf-8"?>
-<p:sld xmlns:a="http://schemas.openxmlformats.org/drawingml/2006/main" xmlns:p="http://schemas.openxmlformats.org/presentationml/2006/main" xmlns:r="http://schemas.openxmlformats.org/officeDocument/2006/relationships">
+<p:sld xmlns:a="http://schemas.openxmlformats.org/drawingml/2006/main" xmlns:r="http://schemas.openxmlformats.org/officeDocument/2006/relationships" xmlns:p="http://schemas.openxmlformats.org/presentationml/2006/main">
   <p:cSld>
     <p:bg>
       <p:bgPr>
@@ -4052,7 +3825,14 @@
         <p:cNvGrpSpPr/>
         <p:nvPr/>
       </p:nvGrpSpPr>
-      <p:grpSpPr/>
+      <p:grpSpPr>
+        <a:xfrm>
+          <a:off x="0" y="0"/>
+          <a:ext cx="0" cy="0"/>
+          <a:chOff x="0" y="0"/>
+          <a:chExt cx="0" cy="0"/>
+        </a:xfrm>
+      </p:grpSpPr>
       <p:sp>
         <p:nvSpPr>
           <p:cNvPr id="2" name="Rounded Rectangle 1"/>
@@ -4095,6 +3875,7 @@
           <a:lstStyle/>
           <a:p>
             <a:pPr algn="ctr"/>
+            <a:endParaRPr/>
           </a:p>
         </p:txBody>
       </p:sp>
@@ -4163,8 +3944,10 @@
               </a:defRPr>
             </a:pPr>
             <a:r>
+              <a:rPr dirty="0" err="1"/>
               <a:t>PawVibe</a:t>
             </a:r>
+            <a:endParaRPr dirty="0"/>
           </a:p>
         </p:txBody>
       </p:sp>
@@ -4177,7 +3960,7 @@
         <p:spPr>
           <a:xfrm>
             <a:off x="1645920" y="2834640"/>
-            <a:ext cx="8686800" cy="731520"/>
+            <a:ext cx="5426486" cy="369332"/>
           </a:xfrm>
           <a:prstGeom prst="rect">
             <a:avLst/>
@@ -4198,7 +3981,16 @@
               </a:defRPr>
             </a:pPr>
             <a:r>
-              <a:t>Bridging Cultural Taste Intelligence to Canine &amp; Feline Compatibility</a:t>
+              <a:rPr dirty="0"/>
+              <a:t>Bridging Cultural Taste Intelligence to </a:t>
+            </a:r>
+            <a:r>
+              <a:rPr lang="en-US" dirty="0"/>
+              <a:t>Pet </a:t>
+            </a:r>
+            <a:r>
+              <a:rPr dirty="0"/>
+              <a:t>Compatibility</a:t>
             </a:r>
           </a:p>
         </p:txBody>
@@ -4233,10 +4025,14 @@
               </a:defRPr>
             </a:pPr>
             <a:r>
+              <a:rPr dirty="0"/>
               <a:t>“Your tastes define your routine. Your routine chooses your pet.”</a:t>
             </a:r>
-            <a:br/>
-            <a:r>
+            <a:br>
+              <a:rPr dirty="0"/>
+            </a:br>
+            <a:r>
+              <a:rPr dirty="0"/>
               <a:t>Turning music, cinema, dining, and neighborhood rhythms into predictive 5D pet lifestyle vectors.</a:t>
             </a:r>
           </a:p>
@@ -4282,11 +4078,19 @@
   <p:clrMapOvr>
     <a:masterClrMapping/>
   </p:clrMapOvr>
+  <mc:AlternateContent xmlns:mc="http://schemas.openxmlformats.org/markup-compatibility/2006">
+    <mc:Choice xmlns:p14="http://schemas.microsoft.com/office/powerpoint/2010/main" Requires="p14">
+      <p:transition spd="slow" p14:dur="2000" advTm="94585"/>
+    </mc:Choice>
+    <mc:Fallback>
+      <p:transition spd="slow" advTm="94585"/>
+    </mc:Fallback>
+  </mc:AlternateContent>
 </p:sld>
 </file>
 
 <file path=ppt/slides/slide2.xml><?xml version="1.0" encoding="utf-8"?>
-<p:sld xmlns:a="http://schemas.openxmlformats.org/drawingml/2006/main" xmlns:p="http://schemas.openxmlformats.org/presentationml/2006/main" xmlns:r="http://schemas.openxmlformats.org/officeDocument/2006/relationships">
+<p:sld xmlns:a="http://schemas.openxmlformats.org/drawingml/2006/main" xmlns:r="http://schemas.openxmlformats.org/officeDocument/2006/relationships" xmlns:p="http://schemas.openxmlformats.org/presentationml/2006/main">
   <p:cSld>
     <p:bg>
       <p:bgPr>
@@ -4302,7 +4106,14 @@
         <p:cNvGrpSpPr/>
         <p:nvPr/>
       </p:nvGrpSpPr>
-      <p:grpSpPr/>
+      <p:grpSpPr>
+        <a:xfrm>
+          <a:off x="0" y="0"/>
+          <a:ext cx="0" cy="0"/>
+          <a:chOff x="0" y="0"/>
+          <a:chExt cx="0" cy="0"/>
+        </a:xfrm>
+      </p:grpSpPr>
       <p:sp>
         <p:nvSpPr>
           <p:cNvPr id="2" name="TextBox 1"/>
@@ -4368,6 +4179,7 @@
               </a:defRPr>
             </a:pPr>
             <a:r>
+              <a:rPr dirty="0"/>
               <a:t>The Pet-Lifestyle Mismatch Crisis</a:t>
             </a:r>
           </a:p>
@@ -4450,6 +4262,7 @@
           <a:lstStyle/>
           <a:p>
             <a:pPr algn="ctr"/>
+            <a:endParaRPr/>
           </a:p>
         </p:txBody>
       </p:sp>
@@ -4483,6 +4296,7 @@
               </a:defRPr>
             </a:pPr>
             <a:r>
+              <a:rPr dirty="0"/>
               <a:t>6.5 Million</a:t>
             </a:r>
           </a:p>
@@ -4495,9 +4309,13 @@
               </a:defRPr>
             </a:pPr>
             <a:r>
+              <a:rPr dirty="0"/>
               <a:t>Pets in US Shelters Annually</a:t>
             </a:r>
-            <a:br/>
+            <a:br>
+              <a:rPr dirty="0"/>
+            </a:br>
+            <a:endParaRPr dirty="0"/>
           </a:p>
           <a:p>
             <a:pPr>
@@ -4508,6 +4326,7 @@
               </a:defRPr>
             </a:pPr>
             <a:r>
+              <a:rPr dirty="0"/>
               <a:t>Over 6.5 million companion animals enter shelters each year. Up to 47% of rehoming decisions stem from lifestyle incompatibilities: energy mismatches, unexpected noise, space constraints, or travel frequency.</a:t>
             </a:r>
           </a:p>
@@ -4555,6 +4374,7 @@
           <a:lstStyle/>
           <a:p>
             <a:pPr algn="ctr"/>
+            <a:endParaRPr/>
           </a:p>
         </p:txBody>
       </p:sp>
@@ -4588,6 +4408,7 @@
               </a:defRPr>
             </a:pPr>
             <a:r>
+              <a:rPr dirty="0"/>
               <a:t>The Flawed Choice</a:t>
             </a:r>
           </a:p>
@@ -4600,9 +4421,13 @@
               </a:defRPr>
             </a:pPr>
             <a:r>
+              <a:rPr dirty="0"/>
               <a:t>Adoption by Aesthetics</a:t>
             </a:r>
-            <a:br/>
+            <a:br>
+              <a:rPr dirty="0"/>
+            </a:br>
+            <a:endParaRPr dirty="0"/>
           </a:p>
           <a:p>
             <a:pPr>
@@ -4613,6 +4438,7 @@
               </a:defRPr>
             </a:pPr>
             <a:r>
+              <a:rPr dirty="0"/>
               <a:t>Owners typically adopt based on social media trends or cute looks (e.g. an apartment worker buying a working Australian Shepherd or Border Collie). People rarely quantify their daily energy, soundscape, and habitat until it's too late.</a:t>
             </a:r>
           </a:p>
@@ -4660,6 +4486,7 @@
           <a:lstStyle/>
           <a:p>
             <a:pPr algn="ctr"/>
+            <a:endParaRPr/>
           </a:p>
         </p:txBody>
       </p:sp>
@@ -4693,6 +4520,7 @@
               </a:defRPr>
             </a:pPr>
             <a:r>
+              <a:rPr dirty="0"/>
               <a:t>The Opportunity</a:t>
             </a:r>
           </a:p>
@@ -4705,9 +4533,13 @@
               </a:defRPr>
             </a:pPr>
             <a:r>
+              <a:rPr dirty="0"/>
               <a:t>Taste Predicts Lifestyle</a:t>
             </a:r>
-            <a:br/>
+            <a:br>
+              <a:rPr dirty="0"/>
+            </a:br>
+            <a:endParaRPr dirty="0"/>
           </a:p>
           <a:p>
             <a:pPr>
@@ -4718,6 +4550,7 @@
               </a:defRPr>
             </a:pPr>
             <a:r>
+              <a:rPr dirty="0"/>
               <a:t>People struggle to evaluate their own physical routine in numbers. However, they easily know their favorite music artists, films, clothing brands, dining spots, and hobbies. These cultural tastes hold the hidden blueprint of how they live.</a:t>
             </a:r>
           </a:p>
@@ -4732,7 +4565,7 @@
 </file>
 
 <file path=ppt/slides/slide3.xml><?xml version="1.0" encoding="utf-8"?>
-<p:sld xmlns:a="http://schemas.openxmlformats.org/drawingml/2006/main" xmlns:p="http://schemas.openxmlformats.org/presentationml/2006/main" xmlns:r="http://schemas.openxmlformats.org/officeDocument/2006/relationships">
+<p:sld xmlns:a="http://schemas.openxmlformats.org/drawingml/2006/main" xmlns:r="http://schemas.openxmlformats.org/officeDocument/2006/relationships" xmlns:p="http://schemas.openxmlformats.org/presentationml/2006/main">
   <p:cSld>
     <p:bg>
       <p:bgPr>
@@ -4748,7 +4581,14 @@
         <p:cNvGrpSpPr/>
         <p:nvPr/>
       </p:nvGrpSpPr>
-      <p:grpSpPr/>
+      <p:grpSpPr>
+        <a:xfrm>
+          <a:off x="0" y="0"/>
+          <a:ext cx="0" cy="0"/>
+          <a:chOff x="0" y="0"/>
+          <a:chExt cx="0" cy="0"/>
+        </a:xfrm>
+      </p:grpSpPr>
       <p:sp>
         <p:nvSpPr>
           <p:cNvPr id="2" name="TextBox 1"/>
@@ -4814,7 +4654,12 @@
               </a:defRPr>
             </a:pPr>
             <a:r>
-              <a:t>Qloo as a Taste-to-Lifestyle Translation Layer</a:t>
+              <a:rPr dirty="0" err="1"/>
+              <a:t>Qloo</a:t>
+            </a:r>
+            <a:r>
+              <a:rPr dirty="0"/>
+              <a:t> as a Taste-to-Lifestyle Translation Layer</a:t>
             </a:r>
           </a:p>
         </p:txBody>
@@ -4896,6 +4741,7 @@
           <a:lstStyle/>
           <a:p>
             <a:pPr algn="ctr"/>
+            <a:endParaRPr/>
           </a:p>
         </p:txBody>
       </p:sp>
@@ -5036,6 +4882,7 @@
           <a:lstStyle/>
           <a:p>
             <a:pPr algn="ctr"/>
+            <a:endParaRPr/>
           </a:p>
         </p:txBody>
       </p:sp>
@@ -5069,7 +4916,16 @@
               </a:defRPr>
             </a:pPr>
             <a:r>
-              <a:t>The PawVibe Translation Engine</a:t>
+              <a:rPr dirty="0"/>
+              <a:t>The </a:t>
+            </a:r>
+            <a:r>
+              <a:rPr dirty="0" err="1"/>
+              <a:t>PawVibe</a:t>
+            </a:r>
+            <a:r>
+              <a:rPr dirty="0"/>
+              <a:t> Translation Engine</a:t>
             </a:r>
           </a:p>
           <a:p>
@@ -5081,10 +4937,11 @@
               </a:defRPr>
             </a:pPr>
             <a:r>
+              <a:rPr dirty="0"/>
               <a:t>1. Ingest Cultural Taste: </a:t>
             </a:r>
             <a:r>
-              <a:rPr>
+              <a:rPr dirty="0">
                 <a:solidFill>
                   <a:srgbClr val="54504A"/>
                 </a:solidFill>
@@ -5101,15 +4958,24 @@
               </a:defRPr>
             </a:pPr>
             <a:r>
+              <a:rPr dirty="0"/>
               <a:t>2. Cross-Domain Extraction: </a:t>
             </a:r>
             <a:r>
-              <a:rPr>
+              <a:rPr dirty="0" err="1">
                 <a:solidFill>
                   <a:srgbClr val="54504A"/>
                 </a:solidFill>
               </a:rPr>
-              <a:t>Qloo's Live Insights API outputs correlated places, brands, and venue tags (Tranquil, Historic, Parks, Nightlife).</a:t>
+              <a:t>Qloo's</a:t>
+            </a:r>
+            <a:r>
+              <a:rPr dirty="0">
+                <a:solidFill>
+                  <a:srgbClr val="54504A"/>
+                </a:solidFill>
+              </a:rPr>
+              <a:t> Live Insights API outputs correlated places, brands, and venue tags (Tranquil, Historic, Parks, Nightlife).</a:t>
             </a:r>
           </a:p>
           <a:p>
@@ -5121,10 +4987,11 @@
               </a:defRPr>
             </a:pPr>
             <a:r>
+              <a:rPr dirty="0"/>
               <a:t>3. 5D Vector Synthesis: </a:t>
             </a:r>
             <a:r>
-              <a:rPr>
+              <a:rPr dirty="0">
                 <a:solidFill>
                   <a:srgbClr val="54504A"/>
                 </a:solidFill>
@@ -5141,10 +5008,11 @@
               </a:defRPr>
             </a:pPr>
             <a:r>
+              <a:rPr dirty="0"/>
               <a:t>4. Mathematical Trait Distance: </a:t>
             </a:r>
             <a:r>
-              <a:rPr>
+              <a:rPr dirty="0">
                 <a:solidFill>
                   <a:srgbClr val="54504A"/>
                 </a:solidFill>
@@ -5163,7 +5031,7 @@
 </file>
 
 <file path=ppt/slides/slide4.xml><?xml version="1.0" encoding="utf-8"?>
-<p:sld xmlns:a="http://schemas.openxmlformats.org/drawingml/2006/main" xmlns:p="http://schemas.openxmlformats.org/presentationml/2006/main" xmlns:r="http://schemas.openxmlformats.org/officeDocument/2006/relationships">
+<p:sld xmlns:a="http://schemas.openxmlformats.org/drawingml/2006/main" xmlns:r="http://schemas.openxmlformats.org/officeDocument/2006/relationships" xmlns:p="http://schemas.openxmlformats.org/presentationml/2006/main">
   <p:cSld>
     <p:bg>
       <p:bgPr>
@@ -5179,7 +5047,14 @@
         <p:cNvGrpSpPr/>
         <p:nvPr/>
       </p:nvGrpSpPr>
-      <p:grpSpPr/>
+      <p:grpSpPr>
+        <a:xfrm>
+          <a:off x="0" y="0"/>
+          <a:ext cx="0" cy="0"/>
+          <a:chOff x="0" y="0"/>
+          <a:chExt cx="0" cy="0"/>
+        </a:xfrm>
+      </p:grpSpPr>
       <p:sp>
         <p:nvSpPr>
           <p:cNvPr id="2" name="TextBox 1"/>
@@ -5327,6 +5202,7 @@
           <a:lstStyle/>
           <a:p>
             <a:pPr algn="ctr"/>
+            <a:endParaRPr/>
           </a:p>
         </p:txBody>
       </p:sp>
@@ -5360,7 +5236,16 @@
               </a:defRPr>
             </a:pPr>
             <a:r>
-              <a:t>Two-Tier Qloo Query Engine</a:t>
+              <a:rPr dirty="0"/>
+              <a:t>Two-Tier </a:t>
+            </a:r>
+            <a:r>
+              <a:rPr dirty="0" err="1"/>
+              <a:t>Qloo</a:t>
+            </a:r>
+            <a:r>
+              <a:rPr dirty="0"/>
+              <a:t> Query Engine</a:t>
             </a:r>
           </a:p>
           <a:p>
@@ -5372,6 +5257,7 @@
               </a:defRPr>
             </a:pPr>
             <a:r>
+              <a:rPr dirty="0"/>
               <a:t>Step 1: Entity Resolution (/search)</a:t>
             </a:r>
           </a:p>
@@ -5384,11 +5270,39 @@
               </a:defRPr>
             </a:pPr>
             <a:r>
-              <a:t>User signals (e.g. 'Radiohead', 'Patagonia') are queried via GET /search?query={item}.</a:t>
-            </a:r>
-            <a:br/>
-            <a:r>
-              <a:t>Returns verified Qloo URN entity IDs (e.g. 70CAE5BF-2F4C... type: urn:entity:artist).</a:t>
+              <a:rPr dirty="0"/>
+              <a:t>User signals (e.g. 'Radiohead', 'Patagonia') are queried via GET /</a:t>
+            </a:r>
+            <a:r>
+              <a:rPr dirty="0" err="1"/>
+              <a:t>search?query</a:t>
+            </a:r>
+            <a:r>
+              <a:rPr dirty="0"/>
+              <a:t>={item}.</a:t>
+            </a:r>
+            <a:br>
+              <a:rPr dirty="0"/>
+            </a:br>
+            <a:r>
+              <a:rPr dirty="0"/>
+              <a:t>Returns verified </a:t>
+            </a:r>
+            <a:r>
+              <a:rPr dirty="0" err="1"/>
+              <a:t>Qloo</a:t>
+            </a:r>
+            <a:r>
+              <a:rPr dirty="0"/>
+              <a:t> URN entity IDs (e.g. 70CAE5BF-2F4C... type: </a:t>
+            </a:r>
+            <a:r>
+              <a:rPr dirty="0" err="1"/>
+              <a:t>urn:entity:artist</a:t>
+            </a:r>
+            <a:r>
+              <a:rPr dirty="0"/>
+              <a:t>).</a:t>
             </a:r>
           </a:p>
           <a:p>
@@ -5400,6 +5314,7 @@
               </a:defRPr>
             </a:pPr>
             <a:r>
+              <a:rPr dirty="0"/>
               <a:t>Step 2: Places Insights (/v2/insights)</a:t>
             </a:r>
           </a:p>
@@ -5412,10 +5327,46 @@
               </a:defRPr>
             </a:pPr>
             <a:r>
-              <a:t>Queries GET /v2/insights with signal.interests.entities={entity_ids}&amp;filter.type=urn:entity:place.</a:t>
-            </a:r>
-            <a:br/>
-            <a:r>
+              <a:rPr dirty="0"/>
+              <a:t>Queries GET /v2/insights with </a:t>
+            </a:r>
+            <a:r>
+              <a:rPr dirty="0" err="1"/>
+              <a:t>signal.interests.entities</a:t>
+            </a:r>
+            <a:r>
+              <a:rPr dirty="0"/>
+              <a:t>={</a:t>
+            </a:r>
+            <a:r>
+              <a:rPr dirty="0" err="1"/>
+              <a:t>entity_ids</a:t>
+            </a:r>
+            <a:r>
+              <a:rPr dirty="0"/>
+              <a:t>}&amp;</a:t>
+            </a:r>
+            <a:r>
+              <a:rPr dirty="0" err="1"/>
+              <a:t>filter.type</a:t>
+            </a:r>
+            <a:r>
+              <a:rPr dirty="0"/>
+              <a:t>=</a:t>
+            </a:r>
+            <a:r>
+              <a:rPr dirty="0" err="1"/>
+              <a:t>urn:entity:place</a:t>
+            </a:r>
+            <a:r>
+              <a:rPr dirty="0"/>
+              <a:t>.</a:t>
+            </a:r>
+            <a:br>
+              <a:rPr dirty="0"/>
+            </a:br>
+            <a:r>
+              <a:rPr dirty="0"/>
               <a:t>Extracts place archetypes &amp; tags: Tranquil, Historic, Nature conservation, Park.</a:t>
             </a:r>
           </a:p>
@@ -5428,6 +5379,7 @@
               </a:defRPr>
             </a:pPr>
             <a:r>
+              <a:rPr dirty="0"/>
               <a:t>Step 3: Brands Insights (/v2/insights)</a:t>
             </a:r>
           </a:p>
@@ -5440,7 +5392,32 @@
               </a:defRPr>
             </a:pPr>
             <a:r>
-              <a:t>Queries filter.type=urn:entity:brand to retrieve correlated lifestyle brands (e.g. Blinkist, Patagonia, Albion Fit).</a:t>
+              <a:rPr dirty="0"/>
+              <a:t>Queries </a:t>
+            </a:r>
+            <a:r>
+              <a:rPr dirty="0" err="1"/>
+              <a:t>filter.type</a:t>
+            </a:r>
+            <a:r>
+              <a:rPr dirty="0"/>
+              <a:t>=</a:t>
+            </a:r>
+            <a:r>
+              <a:rPr dirty="0" err="1"/>
+              <a:t>urn:entity:brand</a:t>
+            </a:r>
+            <a:r>
+              <a:rPr dirty="0"/>
+              <a:t> to retrieve correlated lifestyle brands (e.g. </a:t>
+            </a:r>
+            <a:r>
+              <a:rPr dirty="0" err="1"/>
+              <a:t>Blinkist</a:t>
+            </a:r>
+            <a:r>
+              <a:rPr dirty="0"/>
+              <a:t>, Patagonia, Albion Fit).</a:t>
             </a:r>
           </a:p>
         </p:txBody>
@@ -5487,6 +5464,7 @@
           <a:lstStyle/>
           <a:p>
             <a:pPr algn="ctr"/>
+            <a:endParaRPr/>
           </a:p>
         </p:txBody>
       </p:sp>
@@ -5499,7 +5477,7 @@
           <p:nvPr/>
         </p:nvPicPr>
         <p:blipFill>
-          <a:blip r:embed="rId2"/>
+          <a:blip r:embed="rId3"/>
           <a:stretch>
             <a:fillRect/>
           </a:stretch>
@@ -5523,7 +5501,7 @@
 </file>
 
 <file path=ppt/slides/slide5.xml><?xml version="1.0" encoding="utf-8"?>
-<p:sld xmlns:a="http://schemas.openxmlformats.org/drawingml/2006/main" xmlns:p="http://schemas.openxmlformats.org/presentationml/2006/main" xmlns:r="http://schemas.openxmlformats.org/officeDocument/2006/relationships">
+<p:sld xmlns:a="http://schemas.openxmlformats.org/drawingml/2006/main" xmlns:r="http://schemas.openxmlformats.org/officeDocument/2006/relationships" xmlns:p="http://schemas.openxmlformats.org/presentationml/2006/main">
   <p:cSld>
     <p:bg>
       <p:bgPr>
@@ -5539,7 +5517,14 @@
         <p:cNvGrpSpPr/>
         <p:nvPr/>
       </p:nvGrpSpPr>
-      <p:grpSpPr/>
+      <p:grpSpPr>
+        <a:xfrm>
+          <a:off x="0" y="0"/>
+          <a:ext cx="0" cy="0"/>
+          <a:chOff x="0" y="0"/>
+          <a:chExt cx="0" cy="0"/>
+        </a:xfrm>
+      </p:grpSpPr>
       <p:sp>
         <p:nvSpPr>
           <p:cNvPr id="2" name="TextBox 1"/>
@@ -5687,6 +5672,7 @@
           <a:lstStyle/>
           <a:p>
             <a:pPr algn="ctr"/>
+            <a:endParaRPr/>
           </a:p>
         </p:txBody>
       </p:sp>
@@ -5720,6 +5706,7 @@
               </a:defRPr>
             </a:pPr>
             <a:r>
+              <a:rPr dirty="0"/>
               <a:t>The 5 Lifestyle Dimensions (Scale: 1.0 - 5.0)</a:t>
             </a:r>
           </a:p>
@@ -5732,10 +5719,11 @@
               </a:defRPr>
             </a:pPr>
             <a:r>
+              <a:rPr dirty="0"/>
               <a:t>🏃 Activity Level (Weight: 1.25): </a:t>
             </a:r>
             <a:r>
-              <a:rPr b="0">
+              <a:rPr b="0" dirty="0">
                 <a:solidFill>
                   <a:srgbClr val="54504A"/>
                 </a:solidFill>
@@ -5752,10 +5740,11 @@
               </a:defRPr>
             </a:pPr>
             <a:r>
+              <a:rPr dirty="0"/>
               <a:t>🏡 Living Space (Weight: 1.20): </a:t>
             </a:r>
             <a:r>
-              <a:rPr b="0">
+              <a:rPr b="0" dirty="0">
                 <a:solidFill>
                   <a:srgbClr val="54504A"/>
                 </a:solidFill>
@@ -5772,10 +5761,11 @@
               </a:defRPr>
             </a:pPr>
             <a:r>
+              <a:rPr dirty="0"/>
               <a:t>🤝 Social Exposure (Weight: 1.00): </a:t>
             </a:r>
             <a:r>
-              <a:rPr b="0">
+              <a:rPr b="0" dirty="0">
                 <a:solidFill>
                   <a:srgbClr val="54504A"/>
                 </a:solidFill>
@@ -5792,10 +5782,11 @@
               </a:defRPr>
             </a:pPr>
             <a:r>
+              <a:rPr dirty="0"/>
               <a:t>⏱️ Home Routine (Weight: 1.00): </a:t>
             </a:r>
             <a:r>
-              <a:rPr b="0">
+              <a:rPr b="0" dirty="0">
                 <a:solidFill>
                   <a:srgbClr val="54504A"/>
                 </a:solidFill>
@@ -5812,10 +5803,11 @@
               </a:defRPr>
             </a:pPr>
             <a:r>
+              <a:rPr dirty="0"/>
               <a:t>🔊 Noise &amp; Vibe (Weight: 0.90): </a:t>
             </a:r>
             <a:r>
-              <a:rPr b="0">
+              <a:rPr b="0" dirty="0">
                 <a:solidFill>
                   <a:srgbClr val="54504A"/>
                 </a:solidFill>
@@ -5867,6 +5859,7 @@
           <a:lstStyle/>
           <a:p>
             <a:pPr algn="ctr"/>
+            <a:endParaRPr/>
           </a:p>
         </p:txBody>
       </p:sp>
@@ -5900,6 +5893,7 @@
               </a:defRPr>
             </a:pPr>
             <a:r>
+              <a:rPr dirty="0"/>
               <a:t>The Matching Equation</a:t>
             </a:r>
           </a:p>
@@ -5912,6 +5906,7 @@
               </a:defRPr>
             </a:pPr>
             <a:r>
+              <a:rPr dirty="0"/>
               <a:t>1. Weighted Euclidean Distance:</a:t>
             </a:r>
           </a:p>
@@ -5924,7 +5919,32 @@
               </a:defRPr>
             </a:pPr>
             <a:r>
-              <a:t>D(b) = √ [ Σ w_i · ( Lifestyle_i  -  Breed_Traits_b,i )² ]</a:t>
+              <a:rPr dirty="0"/>
+              <a:t>D(b) = √ [ Σ </a:t>
+            </a:r>
+            <a:r>
+              <a:rPr dirty="0" err="1"/>
+              <a:t>w_i</a:t>
+            </a:r>
+            <a:r>
+              <a:rPr dirty="0"/>
+              <a:t> · ( </a:t>
+            </a:r>
+            <a:r>
+              <a:rPr dirty="0" err="1"/>
+              <a:t>Lifestyle_i</a:t>
+            </a:r>
+            <a:r>
+              <a:rPr dirty="0"/>
+              <a:t>  -  </a:t>
+            </a:r>
+            <a:r>
+              <a:rPr dirty="0" err="1"/>
+              <a:t>Breed_Traits_b,i</a:t>
+            </a:r>
+            <a:r>
+              <a:rPr dirty="0"/>
+              <a:t> )² ]</a:t>
             </a:r>
           </a:p>
           <a:p>
@@ -5936,6 +5956,7 @@
               </a:defRPr>
             </a:pPr>
             <a:r>
+              <a:rPr dirty="0"/>
               <a:t>2. Normalized Match Compatibility:</a:t>
             </a:r>
           </a:p>
@@ -5948,7 +5969,16 @@
               </a:defRPr>
             </a:pPr>
             <a:r>
-              <a:t>Match % = max( 50, (1 - D(b) / D_max) × 100 )</a:t>
+              <a:rPr dirty="0"/>
+              <a:t>Match % = max( 50, (1 - D(b) / </a:t>
+            </a:r>
+            <a:r>
+              <a:rPr dirty="0" err="1"/>
+              <a:t>D_max</a:t>
+            </a:r>
+            <a:r>
+              <a:rPr dirty="0"/>
+              <a:t>) × 100 )</a:t>
             </a:r>
           </a:p>
           <a:p>
@@ -5960,6 +5990,7 @@
               </a:defRPr>
             </a:pPr>
             <a:r>
+              <a:rPr dirty="0"/>
               <a:t>3. Explainable AI Divergence Analysis:</a:t>
             </a:r>
           </a:p>
@@ -5972,6 +6003,7 @@
               </a:defRPr>
             </a:pPr>
             <a:r>
+              <a:rPr dirty="0"/>
               <a:t>The engine compares the user's vector to the breed's traits, isolates the closest alignments, and generates personalized 'Why It Fits Your Vibe' explanations (e.g., 'Matches your peaceful schedule while accommodating your studio space').</a:t>
             </a:r>
           </a:p>
@@ -5986,7 +6018,7 @@
 </file>
 
 <file path=ppt/slides/slide6.xml><?xml version="1.0" encoding="utf-8"?>
-<p:sld xmlns:a="http://schemas.openxmlformats.org/drawingml/2006/main" xmlns:p="http://schemas.openxmlformats.org/presentationml/2006/main" xmlns:r="http://schemas.openxmlformats.org/officeDocument/2006/relationships">
+<p:sld xmlns:a="http://schemas.openxmlformats.org/drawingml/2006/main" xmlns:r="http://schemas.openxmlformats.org/officeDocument/2006/relationships" xmlns:p="http://schemas.openxmlformats.org/presentationml/2006/main">
   <p:cSld>
     <p:bg>
       <p:bgPr>
@@ -6002,7 +6034,14 @@
         <p:cNvGrpSpPr/>
         <p:nvPr/>
       </p:nvGrpSpPr>
-      <p:grpSpPr/>
+      <p:grpSpPr>
+        <a:xfrm>
+          <a:off x="0" y="0"/>
+          <a:ext cx="0" cy="0"/>
+          <a:chOff x="0" y="0"/>
+          <a:chExt cx="0" cy="0"/>
+        </a:xfrm>
+      </p:grpSpPr>
       <p:sp>
         <p:nvSpPr>
           <p:cNvPr id="2" name="TextBox 1"/>
@@ -6150,6 +6189,7 @@
           <a:lstStyle/>
           <a:p>
             <a:pPr algn="ctr"/>
+            <a:endParaRPr/>
           </a:p>
         </p:txBody>
       </p:sp>
@@ -6162,7 +6202,7 @@
           <p:nvPr/>
         </p:nvPicPr>
         <p:blipFill>
-          <a:blip r:embed="rId2"/>
+          <a:blip r:embed="rId3"/>
           <a:stretch>
             <a:fillRect/>
           </a:stretch>
@@ -6219,6 +6259,7 @@
           <a:lstStyle/>
           <a:p>
             <a:pPr algn="ctr"/>
+            <a:endParaRPr/>
           </a:p>
         </p:txBody>
       </p:sp>
@@ -6231,7 +6272,7 @@
           <p:nvPr/>
         </p:nvPicPr>
         <p:blipFill>
-          <a:blip r:embed="rId3"/>
+          <a:blip r:embed="rId4"/>
           <a:stretch>
             <a:fillRect/>
           </a:stretch>
@@ -6255,7 +6296,7 @@
 </file>
 
 <file path=ppt/slides/slide7.xml><?xml version="1.0" encoding="utf-8"?>
-<p:sld xmlns:a="http://schemas.openxmlformats.org/drawingml/2006/main" xmlns:p="http://schemas.openxmlformats.org/presentationml/2006/main" xmlns:r="http://schemas.openxmlformats.org/officeDocument/2006/relationships">
+<p:sld xmlns:a="http://schemas.openxmlformats.org/drawingml/2006/main" xmlns:r="http://schemas.openxmlformats.org/officeDocument/2006/relationships" xmlns:p="http://schemas.openxmlformats.org/presentationml/2006/main">
   <p:cSld>
     <p:bg>
       <p:bgPr>
@@ -6271,7 +6312,14 @@
         <p:cNvGrpSpPr/>
         <p:nvPr/>
       </p:nvGrpSpPr>
-      <p:grpSpPr/>
+      <p:grpSpPr>
+        <a:xfrm>
+          <a:off x="0" y="0"/>
+          <a:ext cx="0" cy="0"/>
+          <a:chOff x="0" y="0"/>
+          <a:chExt cx="0" cy="0"/>
+        </a:xfrm>
+      </p:grpSpPr>
       <p:sp>
         <p:nvSpPr>
           <p:cNvPr id="2" name="TextBox 1"/>
@@ -6302,6 +6350,7 @@
               </a:defRPr>
             </a:pPr>
             <a:r>
+              <a:rPr dirty="0"/>
               <a:t>BUSINESS &amp; MARKET OPPORTUNITY</a:t>
             </a:r>
           </a:p>
@@ -6419,6 +6468,7 @@
           <a:lstStyle/>
           <a:p>
             <a:pPr algn="ctr"/>
+            <a:endParaRPr/>
           </a:p>
         </p:txBody>
       </p:sp>
@@ -6452,6 +6502,7 @@
               </a:defRPr>
             </a:pPr>
             <a:r>
+              <a:rPr dirty="0"/>
               <a:t>$150B+</a:t>
             </a:r>
           </a:p>
@@ -6464,9 +6515,13 @@
               </a:defRPr>
             </a:pPr>
             <a:r>
+              <a:rPr dirty="0"/>
               <a:t>Global Pet Market</a:t>
             </a:r>
-            <a:br/>
+            <a:br>
+              <a:rPr dirty="0"/>
+            </a:br>
+            <a:endParaRPr dirty="0"/>
           </a:p>
           <a:p>
             <a:pPr>
@@ -6477,7 +6532,16 @@
               </a:defRPr>
             </a:pPr>
             <a:r>
-              <a:t>Over 86 million US households own pets. Pet parents spend more on premium nutrition, ethical adoptions, and lifestyle gear than ever before. PawVibe enters as an indispensable discovery gateway at the exact moment of adoption decision.</a:t>
+              <a:rPr dirty="0"/>
+              <a:t>Over 86 million US households own pets. Pet parents spend more on premium nutrition, ethical adoptions, and lifestyle gear than ever before. </a:t>
+            </a:r>
+            <a:r>
+              <a:rPr dirty="0" err="1"/>
+              <a:t>PawVibe</a:t>
+            </a:r>
+            <a:r>
+              <a:rPr dirty="0"/>
+              <a:t> enters as an indispensable discovery gateway at the exact moment of adoption decision.</a:t>
             </a:r>
           </a:p>
         </p:txBody>
@@ -6524,6 +6588,7 @@
           <a:lstStyle/>
           <a:p>
             <a:pPr algn="ctr"/>
+            <a:endParaRPr/>
           </a:p>
         </p:txBody>
       </p:sp>
@@ -6535,7 +6600,7 @@
         </p:nvSpPr>
         <p:spPr>
           <a:xfrm>
-            <a:off x="4572000" y="2011680"/>
+            <a:off x="4526280" y="1828800"/>
             <a:ext cx="2926080" cy="4023360"/>
           </a:xfrm>
           <a:prstGeom prst="rect">
@@ -6557,6 +6622,7 @@
               </a:defRPr>
             </a:pPr>
             <a:r>
+              <a:rPr dirty="0"/>
               <a:t>Monetization</a:t>
             </a:r>
           </a:p>
@@ -6569,9 +6635,13 @@
               </a:defRPr>
             </a:pPr>
             <a:r>
+              <a:rPr dirty="0"/>
               <a:t>High-Margin Channels</a:t>
             </a:r>
-            <a:br/>
+            <a:br>
+              <a:rPr dirty="0"/>
+            </a:br>
+            <a:endParaRPr dirty="0"/>
           </a:p>
           <a:p>
             <a:pPr>
@@ -6582,6 +6652,7 @@
               </a:defRPr>
             </a:pPr>
             <a:r>
+              <a:rPr dirty="0"/>
               <a:t>• Adoption &amp; Rescue Referral Fees with verified ethical breeders and shelter networks.</a:t>
             </a:r>
           </a:p>
@@ -6594,7 +6665,24 @@
               </a:defRPr>
             </a:pPr>
             <a:r>
-              <a:t>• Targeted Affiliate Commerce: Qloo brand affinities recommend tailored gear (e.g. Patagonia owner → Ruffwear outdoor harness).</a:t>
+              <a:rPr dirty="0"/>
+              <a:t>• Targeted Affiliate Commerce: </a:t>
+            </a:r>
+            <a:r>
+              <a:rPr dirty="0" err="1"/>
+              <a:t>Qloo</a:t>
+            </a:r>
+            <a:r>
+              <a:rPr dirty="0"/>
+              <a:t> brand affinities recommend tailored gear (e.g. Patagonia owner → </a:t>
+            </a:r>
+            <a:r>
+              <a:rPr dirty="0" err="1"/>
+              <a:t>Ruffwear</a:t>
+            </a:r>
+            <a:r>
+              <a:rPr dirty="0"/>
+              <a:t> outdoor harness).</a:t>
             </a:r>
           </a:p>
           <a:p>
@@ -6606,6 +6694,7 @@
               </a:defRPr>
             </a:pPr>
             <a:r>
+              <a:rPr dirty="0"/>
               <a:t>• Pet Insurance &amp; Vet Plans integrated at the point of match.</a:t>
             </a:r>
           </a:p>
@@ -6653,6 +6742,7 @@
           <a:lstStyle/>
           <a:p>
             <a:pPr algn="ctr"/>
+            <a:endParaRPr/>
           </a:p>
         </p:txBody>
       </p:sp>
@@ -6686,6 +6776,7 @@
               </a:defRPr>
             </a:pPr>
             <a:r>
+              <a:rPr dirty="0"/>
               <a:t>Social Impact</a:t>
             </a:r>
           </a:p>
@@ -6698,9 +6789,13 @@
               </a:defRPr>
             </a:pPr>
             <a:r>
+              <a:rPr dirty="0"/>
               <a:t>Preventing Surrenders</a:t>
             </a:r>
-            <a:br/>
+            <a:br>
+              <a:rPr dirty="0"/>
+            </a:br>
+            <a:endParaRPr dirty="0"/>
           </a:p>
           <a:p>
             <a:pPr>
@@ -6711,7 +6806,16 @@
               </a:defRPr>
             </a:pPr>
             <a:r>
-              <a:t>By steering adopters away from mismatched breeds and towards pets whose energy and space needs fit their real lives, PawVibe directly targets the root cause of shelter rehoming. Measurable ESG impact combined with venture-scale economics.</a:t>
+              <a:rPr dirty="0"/>
+              <a:t>By steering adopters away from mismatched breeds and towards pets whose energy and space needs fit their real lives, </a:t>
+            </a:r>
+            <a:r>
+              <a:rPr dirty="0" err="1"/>
+              <a:t>PawVibe</a:t>
+            </a:r>
+            <a:r>
+              <a:rPr dirty="0"/>
+              <a:t> directly targets the root cause of shelter rehoming. Measurable ESG impact combined with venture-scale economics.</a:t>
             </a:r>
           </a:p>
         </p:txBody>
@@ -6725,7 +6829,7 @@
 </file>
 
 <file path=ppt/slides/slide8.xml><?xml version="1.0" encoding="utf-8"?>
-<p:sld xmlns:a="http://schemas.openxmlformats.org/drawingml/2006/main" xmlns:p="http://schemas.openxmlformats.org/presentationml/2006/main" xmlns:r="http://schemas.openxmlformats.org/officeDocument/2006/relationships">
+<p:sld xmlns:a="http://schemas.openxmlformats.org/drawingml/2006/main" xmlns:r="http://schemas.openxmlformats.org/officeDocument/2006/relationships" xmlns:p="http://schemas.openxmlformats.org/presentationml/2006/main">
   <p:cSld>
     <p:bg>
       <p:bgPr>
@@ -6741,7 +6845,14 @@
         <p:cNvGrpSpPr/>
         <p:nvPr/>
       </p:nvGrpSpPr>
-      <p:grpSpPr/>
+      <p:grpSpPr>
+        <a:xfrm>
+          <a:off x="0" y="0"/>
+          <a:ext cx="0" cy="0"/>
+          <a:chOff x="0" y="0"/>
+          <a:chExt cx="0" cy="0"/>
+        </a:xfrm>
+      </p:grpSpPr>
       <p:sp>
         <p:nvSpPr>
           <p:cNvPr id="2" name="TextBox 1"/>
@@ -6889,6 +7000,7 @@
           <a:lstStyle/>
           <a:p>
             <a:pPr algn="ctr"/>
+            <a:endParaRPr/>
           </a:p>
         </p:txBody>
       </p:sp>
@@ -6901,7 +7013,7 @@
         <p:spPr>
           <a:xfrm>
             <a:off x="1097280" y="2011680"/>
-            <a:ext cx="10058400" cy="4023360"/>
+            <a:ext cx="10058400" cy="2277547"/>
           </a:xfrm>
           <a:prstGeom prst="rect">
             <a:avLst/>
@@ -6922,6 +7034,7 @@
               </a:defRPr>
             </a:pPr>
             <a:r>
+              <a:rPr dirty="0"/>
               <a:t>Key Takeaways</a:t>
             </a:r>
           </a:p>
@@ -6934,15 +7047,56 @@
               </a:defRPr>
             </a:pPr>
             <a:r>
-              <a:t>1. Novel &amp; Untapped Application of Qloo: </a:t>
-            </a:r>
-            <a:r>
-              <a:rPr b="0">
+              <a:rPr dirty="0"/>
+              <a:t>1. Novel &amp; Untapped Application of </a:t>
+            </a:r>
+            <a:r>
+              <a:rPr dirty="0" err="1"/>
+              <a:t>Qloo</a:t>
+            </a:r>
+            <a:r>
+              <a:rPr dirty="0"/>
+              <a:t>: </a:t>
+            </a:r>
+            <a:r>
+              <a:rPr b="0" dirty="0">
                 <a:solidFill>
                   <a:srgbClr val="54504A"/>
                 </a:solidFill>
               </a:rPr>
-              <a:t>Most hackathon projects use Qloo for playlist or restaurant recommendations. PawVibe proves that cultural affinities can solve critical behavioral problems in animal welfare and consumer lifestyle.</a:t>
+              <a:t>Most hackathon projects use </a:t>
+            </a:r>
+            <a:r>
+              <a:rPr b="0" dirty="0" err="1">
+                <a:solidFill>
+                  <a:srgbClr val="54504A"/>
+                </a:solidFill>
+              </a:rPr>
+              <a:t>Qloo</a:t>
+            </a:r>
+            <a:r>
+              <a:rPr b="0" dirty="0">
+                <a:solidFill>
+                  <a:srgbClr val="54504A"/>
+                </a:solidFill>
+              </a:rPr>
+              <a:t> for playlist or restaurant recommendations. </a:t>
+            </a:r>
+            <a:r>
+              <a:rPr b="0" dirty="0" err="1">
+                <a:solidFill>
+                  <a:srgbClr val="54504A"/>
+                </a:solidFill>
+              </a:rPr>
+              <a:t>PawVibe</a:t>
+            </a:r>
+            <a:r>
+              <a:rPr b="0" dirty="0">
+                <a:solidFill>
+                  <a:srgbClr val="54504A"/>
+                </a:solidFill>
+              </a:rPr>
+              <a:t> proves that cultural affinities can solve critical behavioral problems in animal welfare and consumer lifestyle.</a:t>
             </a:r>
           </a:p>
           <a:p>
@@ -6954,15 +7108,32 @@
               </a:defRPr>
             </a:pPr>
             <a:r>
+              <a:rPr dirty="0"/>
               <a:t>2. Fully Built &amp; Tested with Live API: </a:t>
             </a:r>
             <a:r>
-              <a:rPr b="0">
+              <a:rPr b="0" dirty="0">
                 <a:solidFill>
                   <a:srgbClr val="54504A"/>
                 </a:solidFill>
               </a:rPr>
-              <a:t>Not a mock-up. Authenticated against https://hackathon.api.qloo.com, executing live /search and /v2/insights requests, backed by FastAPI and modern HTML5 Canvas visualization.</a:t>
+              <a:t>Not a mock-up. Authenticated against https://hackathon.api.qloo.com, executing live /search and /v2/insights requests, backed by </a:t>
+            </a:r>
+            <a:r>
+              <a:rPr b="0" dirty="0" err="1">
+                <a:solidFill>
+                  <a:srgbClr val="54504A"/>
+                </a:solidFill>
+              </a:rPr>
+              <a:t>FastAPI</a:t>
+            </a:r>
+            <a:r>
+              <a:rPr b="0" dirty="0">
+                <a:solidFill>
+                  <a:srgbClr val="54504A"/>
+                </a:solidFill>
+              </a:rPr>
+              <a:t> and modern HTML5 Canvas visualization.</a:t>
             </a:r>
           </a:p>
           <a:p>
@@ -6974,10 +7145,11 @@
               </a:defRPr>
             </a:pPr>
             <a:r>
+              <a:rPr dirty="0"/>
               <a:t>3. Luxury Atelier User Experience: </a:t>
             </a:r>
             <a:r>
-              <a:rPr b="0">
+              <a:rPr b="0" dirty="0">
                 <a:solidFill>
                   <a:srgbClr val="54504A"/>
                 </a:solidFill>
@@ -6994,10 +7166,11 @@
               </a:defRPr>
             </a:pPr>
             <a:r>
+              <a:rPr dirty="0"/>
               <a:t>4. Scalable Roadmap: </a:t>
             </a:r>
             <a:r>
-              <a:rPr b="0">
+              <a:rPr b="0" dirty="0">
                 <a:solidFill>
                   <a:srgbClr val="54504A"/>
                 </a:solidFill>
@@ -7006,16 +7179,12 @@
             </a:r>
           </a:p>
           <a:p>
-            <a:br/>
-            <a:pPr>
-              <a:defRPr sz="1400" b="1">
-                <a:solidFill>
-                  <a:srgbClr val="211F1D"/>
-                </a:solidFill>
-              </a:defRPr>
-            </a:pPr>
-            <a:r>
-              <a:t>🐾 Try the live app at: http://localhost:8080   |   Thank You!</a:t>
+            <a:br>
+              <a:rPr dirty="0"/>
+            </a:br>
+            <a:r>
+              <a:rPr dirty="0"/>
+              <a:t>🐾 Thank You!</a:t>
             </a:r>
           </a:p>
         </p:txBody>
@@ -7359,44 +7528,44 @@
         <a:sysClr val="window" lastClr="FFFFFF"/>
       </a:lt1>
       <a:dk2>
-        <a:srgbClr val="1F497D"/>
+        <a:srgbClr val="0E2841"/>
       </a:dk2>
       <a:lt2>
-        <a:srgbClr val="EEECE1"/>
+        <a:srgbClr val="E8E8E8"/>
       </a:lt2>
       <a:accent1>
-        <a:srgbClr val="4F81BD"/>
+        <a:srgbClr val="156082"/>
       </a:accent1>
       <a:accent2>
-        <a:srgbClr val="C0504D"/>
+        <a:srgbClr val="E97132"/>
       </a:accent2>
       <a:accent3>
-        <a:srgbClr val="9BBB59"/>
+        <a:srgbClr val="196B24"/>
       </a:accent3>
       <a:accent4>
-        <a:srgbClr val="8064A2"/>
+        <a:srgbClr val="0F9ED5"/>
       </a:accent4>
       <a:accent5>
-        <a:srgbClr val="4BACC6"/>
+        <a:srgbClr val="A02B93"/>
       </a:accent5>
       <a:accent6>
-        <a:srgbClr val="F79646"/>
+        <a:srgbClr val="4EA72E"/>
       </a:accent6>
       <a:hlink>
-        <a:srgbClr val="0000FF"/>
+        <a:srgbClr val="467886"/>
       </a:hlink>
       <a:folHlink>
-        <a:srgbClr val="800080"/>
+        <a:srgbClr val="96607D"/>
       </a:folHlink>
     </a:clrScheme>
     <a:fontScheme name="Office">
       <a:majorFont>
-        <a:latin typeface="Calibri"/>
+        <a:latin typeface="Aptos Display" panose="02110004020202020204"/>
         <a:ea typeface=""/>
         <a:cs typeface=""/>
-        <a:font script="Jpan" typeface="ＭＳ Ｐゴシック"/>
+        <a:font script="Jpan" typeface="游ゴシック Light"/>
         <a:font script="Hang" typeface="맑은 고딕"/>
-        <a:font script="Hans" typeface="宋体"/>
+        <a:font script="Hans" typeface="等线 Light"/>
         <a:font script="Hant" typeface="新細明體"/>
         <a:font script="Arab" typeface="Times New Roman"/>
         <a:font script="Hebr" typeface="Times New Roman"/>
@@ -7424,14 +7593,31 @@
         <a:font script="Viet" typeface="Times New Roman"/>
         <a:font script="Uigh" typeface="Microsoft Uighur"/>
         <a:font script="Geor" typeface="Sylfaen"/>
+        <a:font script="Armn" typeface="Arial"/>
+        <a:font script="Bugi" typeface="Leelawadee UI"/>
+        <a:font script="Bopo" typeface="Microsoft JhengHei"/>
+        <a:font script="Java" typeface="Javanese Text"/>
+        <a:font script="Lisu" typeface="Segoe UI"/>
+        <a:font script="Mymr" typeface="Myanmar Text"/>
+        <a:font script="Nkoo" typeface="Ebrima"/>
+        <a:font script="Olck" typeface="Nirmala UI"/>
+        <a:font script="Osma" typeface="Ebrima"/>
+        <a:font script="Phag" typeface="Phagspa"/>
+        <a:font script="Syrn" typeface="Estrangelo Edessa"/>
+        <a:font script="Syrj" typeface="Estrangelo Edessa"/>
+        <a:font script="Syre" typeface="Estrangelo Edessa"/>
+        <a:font script="Sora" typeface="Nirmala UI"/>
+        <a:font script="Tale" typeface="Microsoft Tai Le"/>
+        <a:font script="Talu" typeface="Microsoft New Tai Lue"/>
+        <a:font script="Tfng" typeface="Ebrima"/>
       </a:majorFont>
       <a:minorFont>
-        <a:latin typeface="Calibri"/>
+        <a:latin typeface="Aptos" panose="02110004020202020204"/>
         <a:ea typeface=""/>
         <a:cs typeface=""/>
-        <a:font script="Jpan" typeface="ＭＳ Ｐゴシック"/>
+        <a:font script="Jpan" typeface="游ゴシック"/>
         <a:font script="Hang" typeface="맑은 고딕"/>
-        <a:font script="Hans" typeface="宋体"/>
+        <a:font script="Hans" typeface="等线"/>
         <a:font script="Hant" typeface="新細明體"/>
         <a:font script="Arab" typeface="Arial"/>
         <a:font script="Hebr" typeface="Arial"/>
@@ -7459,6 +7645,23 @@
         <a:font script="Viet" typeface="Arial"/>
         <a:font script="Uigh" typeface="Microsoft Uighur"/>
         <a:font script="Geor" typeface="Sylfaen"/>
+        <a:font script="Armn" typeface="Arial"/>
+        <a:font script="Bugi" typeface="Leelawadee UI"/>
+        <a:font script="Bopo" typeface="Microsoft JhengHei"/>
+        <a:font script="Java" typeface="Javanese Text"/>
+        <a:font script="Lisu" typeface="Segoe UI"/>
+        <a:font script="Mymr" typeface="Myanmar Text"/>
+        <a:font script="Nkoo" typeface="Ebrima"/>
+        <a:font script="Olck" typeface="Nirmala UI"/>
+        <a:font script="Osma" typeface="Ebrima"/>
+        <a:font script="Phag" typeface="Phagspa"/>
+        <a:font script="Syrn" typeface="Estrangelo Edessa"/>
+        <a:font script="Syrj" typeface="Estrangelo Edessa"/>
+        <a:font script="Syre" typeface="Estrangelo Edessa"/>
+        <a:font script="Sora" typeface="Nirmala UI"/>
+        <a:font script="Tale" typeface="Microsoft Tai Le"/>
+        <a:font script="Talu" typeface="Microsoft New Tai Lue"/>
+        <a:font script="Tfng" typeface="Ebrima"/>
       </a:minorFont>
     </a:fontScheme>
     <a:fmtScheme name="Office">
@@ -7470,180 +7673,136 @@
           <a:gsLst>
             <a:gs pos="0">
               <a:schemeClr val="phClr">
-                <a:tint val="50000"/>
-                <a:satMod val="300000"/>
+                <a:lumMod val="110000"/>
+                <a:satMod val="105000"/>
+                <a:tint val="67000"/>
               </a:schemeClr>
             </a:gs>
-            <a:gs pos="35000">
+            <a:gs pos="50000">
               <a:schemeClr val="phClr">
-                <a:tint val="37000"/>
-                <a:satMod val="300000"/>
+                <a:lumMod val="105000"/>
+                <a:satMod val="103000"/>
+                <a:tint val="73000"/>
               </a:schemeClr>
             </a:gs>
             <a:gs pos="100000">
               <a:schemeClr val="phClr">
-                <a:tint val="15000"/>
-                <a:satMod val="350000"/>
+                <a:lumMod val="105000"/>
+                <a:satMod val="109000"/>
+                <a:tint val="81000"/>
               </a:schemeClr>
             </a:gs>
           </a:gsLst>
-          <a:lin ang="16200000" scaled="1"/>
+          <a:lin ang="5400000" scaled="0"/>
         </a:gradFill>
         <a:gradFill rotWithShape="1">
           <a:gsLst>
             <a:gs pos="0">
               <a:schemeClr val="phClr">
-                <a:tint val="100000"/>
+                <a:satMod val="103000"/>
+                <a:lumMod val="102000"/>
+                <a:tint val="94000"/>
+              </a:schemeClr>
+            </a:gs>
+            <a:gs pos="50000">
+              <a:schemeClr val="phClr">
+                <a:satMod val="110000"/>
+                <a:lumMod val="100000"/>
                 <a:shade val="100000"/>
-                <a:satMod val="130000"/>
               </a:schemeClr>
             </a:gs>
             <a:gs pos="100000">
               <a:schemeClr val="phClr">
-                <a:tint val="50000"/>
-                <a:shade val="100000"/>
-                <a:satMod val="350000"/>
+                <a:lumMod val="99000"/>
+                <a:satMod val="120000"/>
+                <a:shade val="78000"/>
               </a:schemeClr>
             </a:gs>
           </a:gsLst>
-          <a:lin ang="16200000" scaled="0"/>
+          <a:lin ang="5400000" scaled="0"/>
         </a:gradFill>
       </a:fillStyleLst>
       <a:lnStyleLst>
-        <a:ln w="9525" cap="flat" cmpd="sng" algn="ctr">
+        <a:ln w="12700" cap="flat" cmpd="sng" algn="ctr">
           <a:solidFill>
-            <a:schemeClr val="phClr">
-              <a:shade val="95000"/>
-              <a:satMod val="105000"/>
-            </a:schemeClr>
+            <a:schemeClr val="phClr"/>
           </a:solidFill>
           <a:prstDash val="solid"/>
+          <a:miter lim="800000"/>
+        </a:ln>
+        <a:ln w="19050" cap="flat" cmpd="sng" algn="ctr">
+          <a:solidFill>
+            <a:schemeClr val="phClr"/>
+          </a:solidFill>
+          <a:prstDash val="solid"/>
+          <a:miter lim="800000"/>
         </a:ln>
         <a:ln w="25400" cap="flat" cmpd="sng" algn="ctr">
           <a:solidFill>
             <a:schemeClr val="phClr"/>
           </a:solidFill>
           <a:prstDash val="solid"/>
-        </a:ln>
-        <a:ln w="38100" cap="flat" cmpd="sng" algn="ctr">
-          <a:solidFill>
-            <a:schemeClr val="phClr"/>
-          </a:solidFill>
-          <a:prstDash val="solid"/>
+          <a:miter lim="800000"/>
         </a:ln>
       </a:lnStyleLst>
       <a:effectStyleLst>
         <a:effectStyle>
+          <a:effectLst/>
+        </a:effectStyle>
+        <a:effectStyle>
+          <a:effectLst/>
+        </a:effectStyle>
+        <a:effectStyle>
           <a:effectLst>
-            <a:outerShdw blurRad="40000" dist="20000" dir="5400000" rotWithShape="0">
+            <a:outerShdw blurRad="57150" dist="19050" dir="5400000" algn="ctr" rotWithShape="0">
               <a:srgbClr val="000000">
-                <a:alpha val="38000"/>
+                <a:alpha val="63000"/>
               </a:srgbClr>
             </a:outerShdw>
           </a:effectLst>
-        </a:effectStyle>
-        <a:effectStyle>
-          <a:effectLst>
-            <a:outerShdw blurRad="40000" dist="23000" dir="5400000" rotWithShape="0">
-              <a:srgbClr val="000000">
-                <a:alpha val="35000"/>
-              </a:srgbClr>
-            </a:outerShdw>
-          </a:effectLst>
-        </a:effectStyle>
-        <a:effectStyle>
-          <a:effectLst>
-            <a:outerShdw blurRad="40000" dist="23000" dir="5400000" rotWithShape="0">
-              <a:srgbClr val="000000">
-                <a:alpha val="35000"/>
-              </a:srgbClr>
-            </a:outerShdw>
-          </a:effectLst>
-          <a:scene3d>
-            <a:camera prst="orthographicFront">
-              <a:rot lat="0" lon="0" rev="0"/>
-            </a:camera>
-            <a:lightRig rig="threePt" dir="t">
-              <a:rot lat="0" lon="0" rev="1200000"/>
-            </a:lightRig>
-          </a:scene3d>
-          <a:sp3d>
-            <a:bevelT w="63500" h="25400"/>
-          </a:sp3d>
         </a:effectStyle>
       </a:effectStyleLst>
       <a:bgFillStyleLst>
         <a:solidFill>
           <a:schemeClr val="phClr"/>
         </a:solidFill>
+        <a:solidFill>
+          <a:schemeClr val="phClr">
+            <a:tint val="95000"/>
+            <a:satMod val="170000"/>
+          </a:schemeClr>
+        </a:solidFill>
         <a:gradFill rotWithShape="1">
           <a:gsLst>
             <a:gs pos="0">
               <a:schemeClr val="phClr">
-                <a:tint val="40000"/>
-                <a:satMod val="350000"/>
+                <a:tint val="93000"/>
+                <a:satMod val="150000"/>
+                <a:shade val="98000"/>
+                <a:lumMod val="102000"/>
               </a:schemeClr>
             </a:gs>
-            <a:gs pos="40000">
+            <a:gs pos="50000">
               <a:schemeClr val="phClr">
-                <a:tint val="45000"/>
-                <a:shade val="99000"/>
-                <a:satMod val="350000"/>
+                <a:tint val="98000"/>
+                <a:satMod val="130000"/>
+                <a:shade val="90000"/>
+                <a:lumMod val="103000"/>
               </a:schemeClr>
             </a:gs>
             <a:gs pos="100000">
               <a:schemeClr val="phClr">
-                <a:shade val="20000"/>
-                <a:satMod val="255000"/>
+                <a:shade val="63000"/>
+                <a:satMod val="120000"/>
               </a:schemeClr>
             </a:gs>
           </a:gsLst>
-          <a:path path="circle">
-            <a:fillToRect l="50000" t="-80000" r="50000" b="180000"/>
-          </a:path>
-        </a:gradFill>
-        <a:gradFill rotWithShape="1">
-          <a:gsLst>
-            <a:gs pos="0">
-              <a:schemeClr val="phClr">
-                <a:tint val="80000"/>
-                <a:satMod val="300000"/>
-              </a:schemeClr>
-            </a:gs>
-            <a:gs pos="100000">
-              <a:schemeClr val="phClr">
-                <a:shade val="30000"/>
-                <a:satMod val="200000"/>
-              </a:schemeClr>
-            </a:gs>
-          </a:gsLst>
-          <a:path path="circle">
-            <a:fillToRect l="50000" t="50000" r="50000" b="50000"/>
-          </a:path>
+          <a:lin ang="5400000" scaled="0"/>
         </a:gradFill>
       </a:bgFillStyleLst>
     </a:fmtScheme>
   </a:themeElements>
   <a:objectDefaults>
-    <a:spDef>
-      <a:spPr/>
-      <a:bodyPr/>
-      <a:lstStyle/>
-      <a:style>
-        <a:lnRef idx="1">
-          <a:schemeClr val="accent1"/>
-        </a:lnRef>
-        <a:fillRef idx="3">
-          <a:schemeClr val="accent1"/>
-        </a:fillRef>
-        <a:effectRef idx="2">
-          <a:schemeClr val="accent1"/>
-        </a:effectRef>
-        <a:fontRef idx="minor">
-          <a:schemeClr val="lt1"/>
-        </a:fontRef>
-      </a:style>
-    </a:spDef>
     <a:lnDef>
       <a:spPr/>
       <a:bodyPr/>
@@ -7665,5 +7824,10 @@
     </a:lnDef>
   </a:objectDefaults>
   <a:extraClrSchemeLst/>
+  <a:extLst>
+    <a:ext uri="{05A4C25C-085E-4340-85A3-A5531E510DB2}">
+      <thm15:themeFamily xmlns:thm15="http://schemas.microsoft.com/office/thememl/2012/main" name="Office Theme" id="{2E142A2C-CD16-42D6-873A-C26D2A0506FA}" vid="{1BDDFF52-6CD6-40A5-AB3C-68EB2F1E4D0A}"/>
+    </a:ext>
+  </a:extLst>
 </a:theme>
 </file>
</xml_diff>